<commit_message>
feat: update with official 6-slide SIH template PPTX and 4-page idea description PDF
</commit_message>
<xml_diff>
--- a/presentation/SIH2026_AlertNex_Official_6Slides.pptx
+++ b/presentation/SIH2026_AlertNex_Official_6Slides.pptx
@@ -3093,12 +3093,20 @@
         <p:nvPr/>
       </p:nvGrpSpPr>
       <p:grpSpPr/>
-      <p:sp>
-        <p:nvSpPr>
-          <p:cNvPr id="2" name="Rectangle 1"/>
-          <p:cNvSpPr/>
+      <p:pic>
+        <p:nvPicPr>
+          <p:cNvPr id="2" name="Picture 1" descr="sih_slide1_bg.png"/>
+          <p:cNvPicPr>
+            <a:picLocks noChangeAspect="1"/>
+          </p:cNvPicPr>
           <p:nvPr/>
-        </p:nvSpPr>
+        </p:nvPicPr>
+        <p:blipFill>
+          <a:blip r:embed="rId2"/>
+          <a:stretch>
+            <a:fillRect/>
+          </a:stretch>
+        </p:blipFill>
         <p:spPr>
           <a:xfrm>
             <a:off x="0" y="0"/>
@@ -3107,51 +3115,83 @@
           <a:prstGeom prst="rect">
             <a:avLst/>
           </a:prstGeom>
-          <a:solidFill>
-            <a:srgbClr val="FFFFFF"/>
-          </a:solidFill>
-          <a:ln>
-            <a:noFill/>
-          </a:ln>
-        </p:spPr>
-        <p:style>
-          <a:lnRef idx="1">
-            <a:schemeClr val="accent1"/>
-          </a:lnRef>
-          <a:fillRef idx="3">
-            <a:schemeClr val="accent1"/>
-          </a:fillRef>
-          <a:effectRef idx="2">
-            <a:schemeClr val="accent1"/>
-          </a:effectRef>
-          <a:fontRef idx="minor">
-            <a:schemeClr val="lt1"/>
-          </a:fontRef>
-        </p:style>
-        <p:txBody>
-          <a:bodyPr rtlCol="0" anchor="ctr"/>
-          <a:lstStyle/>
-          <a:p>
-            <a:pPr algn="ctr"/>
-          </a:p>
-        </p:txBody>
-      </p:sp>
-      <p:sp>
-        <p:nvSpPr>
-          <p:cNvPr id="3" name="Rectangle 2"/>
-          <p:cNvSpPr/>
+        </p:spPr>
+      </p:pic>
+      <p:sp>
+        <p:nvSpPr>
+          <p:cNvPr id="3" name="TextBox 2"/>
+          <p:cNvSpPr txBox="1"/>
           <p:nvPr/>
         </p:nvSpPr>
         <p:spPr>
           <a:xfrm>
-            <a:off x="731520" y="365760"/>
-            <a:ext cx="10728655" cy="365760"/>
+            <a:off x="731520" y="685800"/>
+            <a:ext cx="8046720" cy="1188720"/>
           </a:xfrm>
           <a:prstGeom prst="rect">
             <a:avLst/>
           </a:prstGeom>
+          <a:noFill/>
+        </p:spPr>
+        <p:txBody>
+          <a:bodyPr wrap="square">
+            <a:spAutoFit/>
+          </a:bodyPr>
+          <a:lstStyle/>
+          <a:p>
+            <a:pPr>
+              <a:defRPr b="1" sz="2400">
+                <a:solidFill>
+                  <a:srgbClr val="1B365D"/>
+                </a:solidFill>
+              </a:defRPr>
+            </a:pPr>
+            <a:r>
+              <a:t>SMART INDIA HACKATHON 2026</a:t>
+            </a:r>
+          </a:p>
+          <a:p>
+            <a:pPr>
+              <a:defRPr b="1" sz="1800">
+                <a:solidFill>
+                  <a:srgbClr val="1E293B"/>
+                </a:solidFill>
+              </a:defRPr>
+            </a:pPr>
+            <a:r>
+              <a:t>AI-Based Early Warning &amp; Landslide Monitoring System</a:t>
+            </a:r>
+          </a:p>
+          <a:p>
+            <a:pPr>
+              <a:defRPr b="1" sz="1300">
+                <a:solidFill>
+                  <a:srgbClr val="E65100"/>
+                </a:solidFill>
+              </a:defRPr>
+            </a:pPr>
+            <a:r>
+              <a:t>for North Eastern Region (NER) of India</a:t>
+            </a:r>
+          </a:p>
+        </p:txBody>
+      </p:sp>
+      <p:sp>
+        <p:nvSpPr>
+          <p:cNvPr id="4" name="Rounded Rectangle 3"/>
+          <p:cNvSpPr/>
+          <p:nvPr/>
+        </p:nvSpPr>
+        <p:spPr>
+          <a:xfrm>
+            <a:off x="731520" y="1965960"/>
+            <a:ext cx="6949440" cy="2148840"/>
+          </a:xfrm>
+          <a:prstGeom prst="roundRect">
+            <a:avLst/>
+          </a:prstGeom>
           <a:solidFill>
-            <a:srgbClr val="F8FAFC"/>
+            <a:srgbClr val="FAFAFC"/>
           </a:solidFill>
           <a:ln w="12700">
             <a:solidFill>
@@ -3174,65 +3214,146 @@
           </a:fontRef>
         </p:style>
         <p:txBody>
-          <a:bodyPr rtlCol="0" anchor="ctr"/>
+          <a:bodyPr rtlCol="0" anchor="ctr" wrap="square" lIns="182880" tIns="109728"/>
           <a:lstStyle/>
           <a:p>
             <a:pPr algn="ctr">
-              <a:defRPr b="1" sz="1100">
-                <a:solidFill>
-                  <a:srgbClr val="FF6B00"/>
-                </a:solidFill>
-              </a:defRPr>
-            </a:pPr>
-            <a:r>
-              <a:t>SMART INDIA HACKATHON 2026  •  COLLEGE INTERNAL EVALUATION ROUND</a:t>
-            </a:r>
-          </a:p>
-        </p:txBody>
-      </p:sp>
-      <p:sp>
-        <p:nvSpPr>
-          <p:cNvPr id="4" name="TextBox 3"/>
-          <p:cNvSpPr txBox="1"/>
-          <p:nvPr/>
-        </p:nvSpPr>
-        <p:spPr>
-          <a:xfrm>
-            <a:off x="731520" y="868680"/>
-            <a:ext cx="10728655" cy="1097280"/>
-          </a:xfrm>
-          <a:prstGeom prst="rect">
-            <a:avLst/>
-          </a:prstGeom>
-          <a:noFill/>
-        </p:spPr>
-        <p:txBody>
-          <a:bodyPr wrap="square">
-            <a:spAutoFit/>
-          </a:bodyPr>
-          <a:lstStyle/>
-          <a:p>
-            <a:pPr>
-              <a:defRPr b="1" sz="2700">
-                <a:solidFill>
-                  <a:srgbClr val="0A192F"/>
-                </a:solidFill>
-              </a:defRPr>
-            </a:pPr>
-            <a:r>
-              <a:t>AI-Based Early Warning &amp; Landslide Monitoring System</a:t>
-            </a:r>
-          </a:p>
-          <a:p>
-            <a:pPr>
-              <a:defRPr b="1" sz="1700">
-                <a:solidFill>
-                  <a:srgbClr val="FF6B00"/>
-                </a:solidFill>
-              </a:defRPr>
-            </a:pPr>
-            <a:r>
-              <a:t>for North Eastern Region (NER) of India</a:t>
+              <a:defRPr b="1" sz="1000">
+                <a:solidFill>
+                  <a:srgbClr val="1B365D"/>
+                </a:solidFill>
+              </a:defRPr>
+            </a:pPr>
+            <a:r>
+              <a:t>•  Problem Statement ID - </a:t>
+            </a:r>
+            <a:r>
+              <a:rPr b="1" sz="1000">
+                <a:solidFill>
+                  <a:srgbClr val="1E293B"/>
+                </a:solidFill>
+              </a:rPr>
+              <a:t>SIH26001</a:t>
+            </a:r>
+          </a:p>
+          <a:p>
+            <a:pPr>
+              <a:defRPr b="1" sz="1000">
+                <a:solidFill>
+                  <a:srgbClr val="1B365D"/>
+                </a:solidFill>
+              </a:defRPr>
+            </a:pPr>
+            <a:r>
+              <a:t>•  Problem Statement Title - </a:t>
+            </a:r>
+            <a:r>
+              <a:rPr b="0" sz="1000">
+                <a:solidFill>
+                  <a:srgbClr val="1E293B"/>
+                </a:solidFill>
+              </a:rPr>
+              <a:t>AI-Based Early Warning and Landslide Monitoring System in NER</a:t>
+            </a:r>
+          </a:p>
+          <a:p>
+            <a:pPr>
+              <a:defRPr b="1" sz="1000">
+                <a:solidFill>
+                  <a:srgbClr val="1B365D"/>
+                </a:solidFill>
+              </a:defRPr>
+            </a:pPr>
+            <a:r>
+              <a:t>•  Theme - </a:t>
+            </a:r>
+            <a:r>
+              <a:rPr b="0" sz="1000">
+                <a:solidFill>
+                  <a:srgbClr val="1E293B"/>
+                </a:solidFill>
+              </a:rPr>
+              <a:t>Disaster Management</a:t>
+            </a:r>
+          </a:p>
+          <a:p>
+            <a:pPr>
+              <a:defRPr b="1" sz="1000">
+                <a:solidFill>
+                  <a:srgbClr val="1B365D"/>
+                </a:solidFill>
+              </a:defRPr>
+            </a:pPr>
+            <a:r>
+              <a:t>•  PS Category - </a:t>
+            </a:r>
+            <a:r>
+              <a:rPr b="0" sz="1000">
+                <a:solidFill>
+                  <a:srgbClr val="1E293B"/>
+                </a:solidFill>
+              </a:rPr>
+              <a:t>Software Edition</a:t>
+            </a:r>
+          </a:p>
+          <a:p>
+            <a:pPr>
+              <a:defRPr b="1" sz="1000">
+                <a:solidFill>
+                  <a:srgbClr val="1B365D"/>
+                </a:solidFill>
+              </a:defRPr>
+            </a:pPr>
+            <a:r>
+              <a:t>•  Organization - </a:t>
+            </a:r>
+            <a:r>
+              <a:rPr b="0" sz="1000">
+                <a:solidFill>
+                  <a:srgbClr val="1E293B"/>
+                </a:solidFill>
+              </a:rPr>
+              <a:t>Ministry of Development of North Eastern Region (MDoNER)</a:t>
+            </a:r>
+          </a:p>
+          <a:p>
+            <a:pPr>
+              <a:defRPr b="1" sz="1000">
+                <a:solidFill>
+                  <a:srgbClr val="1B365D"/>
+                </a:solidFill>
+              </a:defRPr>
+            </a:pPr>
+            <a:r>
+              <a:t>•  Team Name - </a:t>
+            </a:r>
+            <a:r>
+              <a:rPr b="1" sz="1000">
+                <a:solidFill>
+                  <a:srgbClr val="E65100"/>
+                </a:solidFill>
+              </a:rPr>
+              <a:t>AlertNex</a:t>
+            </a:r>
+          </a:p>
+          <a:p>
+            <a:pPr>
+              <a:defRPr b="1" sz="1000">
+                <a:solidFill>
+                  <a:srgbClr val="1B365D"/>
+                </a:solidFill>
+              </a:defRPr>
+            </a:pPr>
+            <a:r>
+              <a:t>•  Team Leader - </a:t>
+            </a:r>
+            <a:r>
+              <a:rPr b="1" sz="1000">
+                <a:solidFill>
+                  <a:srgbClr val="E65100"/>
+                </a:solidFill>
+              </a:rPr>
+              <a:t>Ayush Kumar</a:t>
             </a:r>
           </a:p>
         </p:txBody>
@@ -3245,16 +3366,16 @@
         </p:nvSpPr>
         <p:spPr>
           <a:xfrm>
-            <a:off x="731520" y="2148840"/>
-            <a:ext cx="3931920" cy="4160520"/>
+            <a:off x="731520" y="4206240"/>
+            <a:ext cx="6949440" cy="2103120"/>
           </a:xfrm>
           <a:prstGeom prst="roundRect">
             <a:avLst/>
           </a:prstGeom>
           <a:solidFill>
-            <a:srgbClr val="F8FAFC"/>
+            <a:srgbClr val="FAFAFC"/>
           </a:solidFill>
-          <a:ln w="15240">
+          <a:ln w="12700">
             <a:solidFill>
               <a:srgbClr val="CBD5E1"/>
             </a:solidFill>
@@ -3275,446 +3396,152 @@
           </a:fontRef>
         </p:style>
         <p:txBody>
-          <a:bodyPr rtlCol="0" anchor="ctr" wrap="square" lIns="201168" tIns="182880"/>
+          <a:bodyPr rtlCol="0" anchor="ctr" wrap="square" lIns="182880" tIns="91440"/>
           <a:lstStyle/>
           <a:p>
             <a:pPr algn="ctr">
-              <a:defRPr b="1" sz="1200">
-                <a:solidFill>
-                  <a:srgbClr val="0A192F"/>
-                </a:solidFill>
-              </a:defRPr>
-            </a:pPr>
-            <a:r>
-              <a:t>PROJECT SPECIFICATIONS</a:t>
-            </a:r>
-          </a:p>
-          <a:p>
-            <a:pPr>
-              <a:defRPr b="1" sz="980">
-                <a:solidFill>
-                  <a:srgbClr val="0A192F"/>
-                </a:solidFill>
-              </a:defRPr>
-            </a:pPr>
-            <a:r>
-              <a:t>Problem Statement ID:</a:t>
-            </a:r>
-          </a:p>
-          <a:p>
-            <a:pPr>
-              <a:defRPr sz="950">
+              <a:defRPr b="1" sz="1050">
+                <a:solidFill>
+                  <a:srgbClr val="E65100"/>
+                </a:solidFill>
+              </a:defRPr>
+            </a:pPr>
+            <a:r>
+              <a:t>TEAM ALERTSPEC ROSTER (ALL 6 MEMBERS)</a:t>
+            </a:r>
+          </a:p>
+          <a:p>
+            <a:pPr>
+              <a:defRPr b="1" sz="880">
+                <a:solidFill>
+                  <a:srgbClr val="E65100"/>
+                </a:solidFill>
+              </a:defRPr>
+            </a:pPr>
+            <a:r>
+              <a:t>1. Ayush Kumar  [Team Leader]: </a:t>
+            </a:r>
+            <a:r>
+              <a:rPr sz="850">
                 <a:solidFill>
                   <a:srgbClr val="1E293B"/>
                 </a:solidFill>
-              </a:defRPr>
-            </a:pPr>
-            <a:r>
-              <a:t>  SIH26001</a:t>
-            </a:r>
-          </a:p>
-          <a:p>
-            <a:pPr>
-              <a:defRPr b="1" sz="980">
-                <a:solidFill>
-                  <a:srgbClr val="0A192F"/>
-                </a:solidFill>
-              </a:defRPr>
-            </a:pPr>
-            <a:r>
-              <a:t>Theme:</a:t>
-            </a:r>
-          </a:p>
-          <a:p>
-            <a:pPr>
-              <a:defRPr sz="950">
+              </a:rPr>
+              <a:t>AI/ML, System Architecture, Overall Coordination</a:t>
+            </a:r>
+          </a:p>
+          <a:p>
+            <a:pPr>
+              <a:defRPr b="1" sz="880">
+                <a:solidFill>
+                  <a:srgbClr val="1B365D"/>
+                </a:solidFill>
+              </a:defRPr>
+            </a:pPr>
+            <a:r>
+              <a:t>2. Prerana Mondal  [Member]: </a:t>
+            </a:r>
+            <a:r>
+              <a:rPr sz="850">
                 <a:solidFill>
                   <a:srgbClr val="1E293B"/>
                 </a:solidFill>
-              </a:defRPr>
-            </a:pPr>
-            <a:r>
-              <a:t>  Disaster Management</a:t>
-            </a:r>
-          </a:p>
-          <a:p>
-            <a:pPr>
-              <a:defRPr b="1" sz="980">
-                <a:solidFill>
-                  <a:srgbClr val="0A192F"/>
-                </a:solidFill>
-              </a:defRPr>
-            </a:pPr>
-            <a:r>
-              <a:t>Category:</a:t>
-            </a:r>
-          </a:p>
-          <a:p>
-            <a:pPr>
-              <a:defRPr sz="950">
+              </a:rPr>
+              <a:t>Frontend Development, UI/UX, Data Visualization</a:t>
+            </a:r>
+          </a:p>
+          <a:p>
+            <a:pPr>
+              <a:defRPr b="1" sz="880">
+                <a:solidFill>
+                  <a:srgbClr val="1B365D"/>
+                </a:solidFill>
+              </a:defRPr>
+            </a:pPr>
+            <a:r>
+              <a:t>3. Sondeep Kumar  [Member]: </a:t>
+            </a:r>
+            <a:r>
+              <a:rPr sz="850">
                 <a:solidFill>
                   <a:srgbClr val="1E293B"/>
                 </a:solidFill>
-              </a:defRPr>
-            </a:pPr>
-            <a:r>
-              <a:t>  Software Edition</a:t>
-            </a:r>
-          </a:p>
-          <a:p>
-            <a:pPr>
-              <a:defRPr b="1" sz="980">
-                <a:solidFill>
-                  <a:srgbClr val="0A192F"/>
-                </a:solidFill>
-              </a:defRPr>
-            </a:pPr>
-            <a:r>
-              <a:t>Ministry / Organization:</a:t>
-            </a:r>
-          </a:p>
-          <a:p>
-            <a:pPr>
-              <a:defRPr sz="950">
+              </a:rPr>
+              <a:t>Backend Development, Database, API Integration</a:t>
+            </a:r>
+          </a:p>
+          <a:p>
+            <a:pPr>
+              <a:defRPr b="1" sz="880">
+                <a:solidFill>
+                  <a:srgbClr val="1B365D"/>
+                </a:solidFill>
+              </a:defRPr>
+            </a:pPr>
+            <a:r>
+              <a:t>4. Shinjini Lohar  [Member]: </a:t>
+            </a:r>
+            <a:r>
+              <a:rPr sz="850">
                 <a:solidFill>
                   <a:srgbClr val="1E293B"/>
                 </a:solidFill>
-              </a:defRPr>
-            </a:pPr>
-            <a:r>
-              <a:t>  Ministry of Development of North Eastern Region (MDoNER)</a:t>
-            </a:r>
-          </a:p>
-          <a:p>
-            <a:pPr>
-              <a:defRPr b="1" sz="980">
-                <a:solidFill>
-                  <a:srgbClr val="0A192F"/>
-                </a:solidFill>
-              </a:defRPr>
-            </a:pPr>
-            <a:r>
-              <a:t>Team Name:</a:t>
-            </a:r>
-          </a:p>
-          <a:p>
-            <a:pPr>
-              <a:defRPr sz="950">
+              </a:rPr>
+              <a:t>AI/ML, Computer Vision, Data Processing</a:t>
+            </a:r>
+          </a:p>
+          <a:p>
+            <a:pPr>
+              <a:defRPr b="1" sz="880">
+                <a:solidFill>
+                  <a:srgbClr val="1B365D"/>
+                </a:solidFill>
+              </a:defRPr>
+            </a:pPr>
+            <a:r>
+              <a:t>5. Subham Kumar Modi  [Member]: </a:t>
+            </a:r>
+            <a:r>
+              <a:rPr sz="850">
                 <a:solidFill>
                   <a:srgbClr val="1E293B"/>
                 </a:solidFill>
-              </a:defRPr>
-            </a:pPr>
-            <a:r>
-              <a:t>  AlertNex</a:t>
-            </a:r>
-          </a:p>
-          <a:p>
-            <a:pPr>
-              <a:defRPr b="1" sz="980">
-                <a:solidFill>
-                  <a:srgbClr val="0A192F"/>
-                </a:solidFill>
-              </a:defRPr>
-            </a:pPr>
-            <a:r>
-              <a:t>Team Leader:</a:t>
-            </a:r>
-          </a:p>
-          <a:p>
-            <a:pPr>
-              <a:defRPr sz="950">
+              </a:rPr>
+              <a:t>GIS Analysis, Mobile Application, QA Testing</a:t>
+            </a:r>
+          </a:p>
+          <a:p>
+            <a:pPr>
+              <a:defRPr b="1" sz="880">
+                <a:solidFill>
+                  <a:srgbClr val="1B365D"/>
+                </a:solidFill>
+              </a:defRPr>
+            </a:pPr>
+            <a:r>
+              <a:t>6. Rahul Deo  [Member]: </a:t>
+            </a:r>
+            <a:r>
+              <a:rPr sz="850">
                 <a:solidFill>
                   <a:srgbClr val="1E293B"/>
                 </a:solidFill>
-              </a:defRPr>
-            </a:pPr>
-            <a:r>
-              <a:t>  Ayush Kumar</a:t>
-            </a:r>
-          </a:p>
-          <a:p>
-            <a:pPr>
-              <a:defRPr b="1" sz="980">
-                <a:solidFill>
-                  <a:srgbClr val="0A192F"/>
-                </a:solidFill>
-              </a:defRPr>
-            </a:pPr>
-            <a:r>
-              <a:t>Core Focus:</a:t>
-            </a:r>
-          </a:p>
-          <a:p>
-            <a:pPr>
-              <a:defRPr sz="950">
-                <a:solidFill>
-                  <a:srgbClr val="1E293B"/>
-                </a:solidFill>
-              </a:defRPr>
-            </a:pPr>
-            <a:r>
-              <a:t>  Dynamic Risk + Connectivity Impact + Offline Ground Sync</a:t>
-            </a:r>
-          </a:p>
-        </p:txBody>
-      </p:sp>
-      <p:sp>
-        <p:nvSpPr>
-          <p:cNvPr id="6" name="Rounded Rectangle 5"/>
-          <p:cNvSpPr/>
-          <p:nvPr/>
-        </p:nvSpPr>
-        <p:spPr>
-          <a:xfrm>
-            <a:off x="4846320" y="2148840"/>
-            <a:ext cx="6613855" cy="4160520"/>
-          </a:xfrm>
-          <a:prstGeom prst="roundRect">
-            <a:avLst/>
-          </a:prstGeom>
-          <a:solidFill>
-            <a:srgbClr val="F8FAFC"/>
-          </a:solidFill>
-          <a:ln w="15240">
-            <a:solidFill>
-              <a:srgbClr val="CBD5E1"/>
-            </a:solidFill>
-          </a:ln>
-        </p:spPr>
-        <p:style>
-          <a:lnRef idx="1">
-            <a:schemeClr val="accent1"/>
-          </a:lnRef>
-          <a:fillRef idx="3">
-            <a:schemeClr val="accent1"/>
-          </a:fillRef>
-          <a:effectRef idx="2">
-            <a:schemeClr val="accent1"/>
-          </a:effectRef>
-          <a:fontRef idx="minor">
-            <a:schemeClr val="lt1"/>
-          </a:fontRef>
-        </p:style>
-        <p:txBody>
-          <a:bodyPr rtlCol="0" anchor="ctr" wrap="square" lIns="228600" tIns="164592"/>
-          <a:lstStyle/>
-          <a:p>
-            <a:pPr algn="ctr">
-              <a:defRPr b="1" sz="1200">
-                <a:solidFill>
-                  <a:srgbClr val="FF6B00"/>
-                </a:solidFill>
-              </a:defRPr>
-            </a:pPr>
-            <a:r>
-              <a:t>TEAM ALERTSPEC PROFILE — ALL 6 MEMBERS</a:t>
-            </a:r>
-          </a:p>
-          <a:p>
-            <a:pPr>
-              <a:defRPr b="1" sz="1000">
-                <a:solidFill>
-                  <a:srgbClr val="FF6B00"/>
-                </a:solidFill>
-              </a:defRPr>
-            </a:pPr>
-            <a:r>
-              <a:t>1. Ayush Kumar </a:t>
-            </a:r>
-            <a:r>
-              <a:rPr b="1" sz="950">
-                <a:solidFill>
-                  <a:srgbClr val="008A4B"/>
-                </a:solidFill>
               </a:rPr>
-              <a:t>|  Team Leader</a:t>
-            </a:r>
-          </a:p>
-          <a:p>
-            <a:pPr>
-              <a:defRPr sz="900">
-                <a:solidFill>
-                  <a:srgbClr val="64748B"/>
-                </a:solidFill>
-              </a:defRPr>
-            </a:pPr>
-            <a:r>
-              <a:t>   Responsibilities: AI/ML, System Architecture, Overall Coordination</a:t>
-            </a:r>
-          </a:p>
-          <a:p>
-            <a:pPr>
-              <a:defRPr b="1" sz="1000">
-                <a:solidFill>
-                  <a:srgbClr val="0A192F"/>
-                </a:solidFill>
-              </a:defRPr>
-            </a:pPr>
-            <a:r>
-              <a:t>2. Prerana Mondal </a:t>
-            </a:r>
-            <a:r>
-              <a:rPr b="1" sz="950">
-                <a:solidFill>
-                  <a:srgbClr val="0A192F"/>
-                </a:solidFill>
-              </a:rPr>
-              <a:t>|  Team Member</a:t>
-            </a:r>
-          </a:p>
-          <a:p>
-            <a:pPr>
-              <a:defRPr sz="900">
-                <a:solidFill>
-                  <a:srgbClr val="64748B"/>
-                </a:solidFill>
-              </a:defRPr>
-            </a:pPr>
-            <a:r>
-              <a:t>   Responsibilities: Frontend Development, UI/UX, Data Visualization</a:t>
-            </a:r>
-          </a:p>
-          <a:p>
-            <a:pPr>
-              <a:defRPr b="1" sz="1000">
-                <a:solidFill>
-                  <a:srgbClr val="0A192F"/>
-                </a:solidFill>
-              </a:defRPr>
-            </a:pPr>
-            <a:r>
-              <a:t>3. Sondeep Kumar </a:t>
-            </a:r>
-            <a:r>
-              <a:rPr b="1" sz="950">
-                <a:solidFill>
-                  <a:srgbClr val="0A192F"/>
-                </a:solidFill>
-              </a:rPr>
-              <a:t>|  Team Member</a:t>
-            </a:r>
-          </a:p>
-          <a:p>
-            <a:pPr>
-              <a:defRPr sz="900">
-                <a:solidFill>
-                  <a:srgbClr val="64748B"/>
-                </a:solidFill>
-              </a:defRPr>
-            </a:pPr>
-            <a:r>
-              <a:t>   Responsibilities: Backend Development, Database, API Integration</a:t>
-            </a:r>
-          </a:p>
-          <a:p>
-            <a:pPr>
-              <a:defRPr b="1" sz="1000">
-                <a:solidFill>
-                  <a:srgbClr val="0A192F"/>
-                </a:solidFill>
-              </a:defRPr>
-            </a:pPr>
-            <a:r>
-              <a:t>4. Shinjini Lohar </a:t>
-            </a:r>
-            <a:r>
-              <a:rPr b="1" sz="950">
-                <a:solidFill>
-                  <a:srgbClr val="0A192F"/>
-                </a:solidFill>
-              </a:rPr>
-              <a:t>|  Team Member</a:t>
-            </a:r>
-          </a:p>
-          <a:p>
-            <a:pPr>
-              <a:defRPr sz="900">
-                <a:solidFill>
-                  <a:srgbClr val="64748B"/>
-                </a:solidFill>
-              </a:defRPr>
-            </a:pPr>
-            <a:r>
-              <a:t>   Responsibilities: AI/ML, Computer Vision, Data Processing</a:t>
-            </a:r>
-          </a:p>
-          <a:p>
-            <a:pPr>
-              <a:defRPr b="1" sz="1000">
-                <a:solidFill>
-                  <a:srgbClr val="0A192F"/>
-                </a:solidFill>
-              </a:defRPr>
-            </a:pPr>
-            <a:r>
-              <a:t>5. Subham Kumar Modi </a:t>
-            </a:r>
-            <a:r>
-              <a:rPr b="1" sz="950">
-                <a:solidFill>
-                  <a:srgbClr val="0A192F"/>
-                </a:solidFill>
-              </a:rPr>
-              <a:t>|  Team Member</a:t>
-            </a:r>
-          </a:p>
-          <a:p>
-            <a:pPr>
-              <a:defRPr sz="900">
-                <a:solidFill>
-                  <a:srgbClr val="64748B"/>
-                </a:solidFill>
-              </a:defRPr>
-            </a:pPr>
-            <a:r>
-              <a:t>   Responsibilities: GIS Analysis, Mobile Application, QA Testing</a:t>
-            </a:r>
-          </a:p>
-          <a:p>
-            <a:pPr>
-              <a:defRPr b="1" sz="1000">
-                <a:solidFill>
-                  <a:srgbClr val="0A192F"/>
-                </a:solidFill>
-              </a:defRPr>
-            </a:pPr>
-            <a:r>
-              <a:t>6. Rahul Deo </a:t>
-            </a:r>
-            <a:r>
-              <a:rPr b="1" sz="950">
-                <a:solidFill>
-                  <a:srgbClr val="0A192F"/>
-                </a:solidFill>
-              </a:rPr>
-              <a:t>|  Team Member</a:t>
-            </a:r>
-          </a:p>
-          <a:p>
-            <a:pPr>
-              <a:defRPr sz="900">
-                <a:solidFill>
-                  <a:srgbClr val="64748B"/>
-                </a:solidFill>
-              </a:defRPr>
-            </a:pPr>
-            <a:r>
-              <a:t>   Responsibilities: Cloud Infrastructure, DevOps, Testing and Security</a:t>
-            </a:r>
-          </a:p>
-        </p:txBody>
-      </p:sp>
-      <p:sp>
-        <p:nvSpPr>
-          <p:cNvPr id="7" name="TextBox 6"/>
+              <a:t>Cloud Infrastructure, DevOps, Testing &amp; Security</a:t>
+            </a:r>
+          </a:p>
+        </p:txBody>
+      </p:sp>
+      <p:sp>
+        <p:nvSpPr>
+          <p:cNvPr id="6" name="TextBox 5"/>
           <p:cNvSpPr txBox="1"/>
           <p:nvPr/>
         </p:nvSpPr>
         <p:spPr>
           <a:xfrm>
             <a:off x="731520" y="6446520"/>
-            <a:ext cx="8686800" cy="292608"/>
+            <a:ext cx="8686800" cy="274320"/>
           </a:xfrm>
           <a:prstGeom prst="rect">
             <a:avLst/>
@@ -3742,14 +3569,14 @@
       </p:sp>
       <p:sp>
         <p:nvSpPr>
-          <p:cNvPr id="8" name="TextBox 7"/>
+          <p:cNvPr id="7" name="TextBox 6"/>
           <p:cNvSpPr txBox="1"/>
           <p:nvPr/>
         </p:nvSpPr>
         <p:spPr>
           <a:xfrm>
             <a:off x="9601200" y="6446520"/>
-            <a:ext cx="1858975" cy="292608"/>
+            <a:ext cx="1858975" cy="274320"/>
           </a:xfrm>
           <a:prstGeom prst="rect">
             <a:avLst/>
@@ -3765,7 +3592,7 @@
             <a:pPr algn="r">
               <a:defRPr b="1" sz="950">
                 <a:solidFill>
-                  <a:srgbClr val="0A192F"/>
+                  <a:srgbClr val="1B365D"/>
                 </a:solidFill>
               </a:defRPr>
             </a:pPr>
@@ -3793,12 +3620,20 @@
         <p:nvPr/>
       </p:nvGrpSpPr>
       <p:grpSpPr/>
-      <p:sp>
-        <p:nvSpPr>
-          <p:cNvPr id="2" name="Rectangle 1"/>
-          <p:cNvSpPr/>
+      <p:pic>
+        <p:nvPicPr>
+          <p:cNvPr id="2" name="Picture 1" descr="sih_content_bg.png"/>
+          <p:cNvPicPr>
+            <a:picLocks noChangeAspect="1"/>
+          </p:cNvPicPr>
           <p:nvPr/>
-        </p:nvSpPr>
+        </p:nvPicPr>
+        <p:blipFill>
+          <a:blip r:embed="rId2"/>
+          <a:stretch>
+            <a:fillRect/>
+          </a:stretch>
+        </p:blipFill>
         <p:spPr>
           <a:xfrm>
             <a:off x="0" y="0"/>
@@ -3807,35 +3642,8 @@
           <a:prstGeom prst="rect">
             <a:avLst/>
           </a:prstGeom>
-          <a:solidFill>
-            <a:srgbClr val="FFFFFF"/>
-          </a:solidFill>
-          <a:ln>
-            <a:noFill/>
-          </a:ln>
-        </p:spPr>
-        <p:style>
-          <a:lnRef idx="1">
-            <a:schemeClr val="accent1"/>
-          </a:lnRef>
-          <a:fillRef idx="3">
-            <a:schemeClr val="accent1"/>
-          </a:fillRef>
-          <a:effectRef idx="2">
-            <a:schemeClr val="accent1"/>
-          </a:effectRef>
-          <a:fontRef idx="minor">
-            <a:schemeClr val="lt1"/>
-          </a:fontRef>
-        </p:style>
-        <p:txBody>
-          <a:bodyPr rtlCol="0" anchor="ctr"/>
-          <a:lstStyle/>
-          <a:p>
-            <a:pPr algn="ctr"/>
-          </a:p>
-        </p:txBody>
-      </p:sp>
+        </p:spPr>
+      </p:pic>
       <p:sp>
         <p:nvSpPr>
           <p:cNvPr id="3" name="TextBox 2"/>
@@ -3844,7 +3652,7 @@
         </p:nvSpPr>
         <p:spPr>
           <a:xfrm>
-            <a:off x="731520" y="256032"/>
+            <a:off x="731520" y="228600"/>
             <a:ext cx="4114800" cy="320040"/>
           </a:xfrm>
           <a:prstGeom prst="rect">
@@ -3861,7 +3669,7 @@
             <a:pPr>
               <a:defRPr b="1" sz="1100">
                 <a:solidFill>
-                  <a:srgbClr val="FF6B00"/>
+                  <a:srgbClr val="E65100"/>
                 </a:solidFill>
               </a:defRPr>
             </a:pPr>
@@ -3879,8 +3687,8 @@
         </p:nvSpPr>
         <p:spPr>
           <a:xfrm>
-            <a:off x="6583680" y="256032"/>
-            <a:ext cx="4873752" cy="320040"/>
+            <a:off x="6217920" y="228600"/>
+            <a:ext cx="5242255" cy="320040"/>
           </a:xfrm>
           <a:prstGeom prst="rect">
             <a:avLst/>
@@ -3896,7 +3704,7 @@
             <a:pPr algn="r">
               <a:defRPr b="1" sz="1000">
                 <a:solidFill>
-                  <a:srgbClr val="0A192F"/>
+                  <a:srgbClr val="1B365D"/>
                 </a:solidFill>
               </a:defRPr>
             </a:pPr>
@@ -3908,56 +3716,13 @@
       </p:sp>
       <p:sp>
         <p:nvSpPr>
-          <p:cNvPr id="5" name="Rectangle 4"/>
-          <p:cNvSpPr/>
-          <p:nvPr/>
-        </p:nvSpPr>
-        <p:spPr>
-          <a:xfrm>
-            <a:off x="731520" y="621792"/>
-            <a:ext cx="10728655" cy="18288"/>
-          </a:xfrm>
-          <a:prstGeom prst="rect">
-            <a:avLst/>
-          </a:prstGeom>
-          <a:solidFill>
-            <a:srgbClr val="E2E8F0"/>
-          </a:solidFill>
-          <a:ln>
-            <a:noFill/>
-          </a:ln>
-        </p:spPr>
-        <p:style>
-          <a:lnRef idx="1">
-            <a:schemeClr val="accent1"/>
-          </a:lnRef>
-          <a:fillRef idx="3">
-            <a:schemeClr val="accent1"/>
-          </a:fillRef>
-          <a:effectRef idx="2">
-            <a:schemeClr val="accent1"/>
-          </a:effectRef>
-          <a:fontRef idx="minor">
-            <a:schemeClr val="lt1"/>
-          </a:fontRef>
-        </p:style>
-        <p:txBody>
-          <a:bodyPr rtlCol="0" anchor="ctr"/>
-          <a:lstStyle/>
-          <a:p>
-            <a:pPr algn="ctr"/>
-          </a:p>
-        </p:txBody>
-      </p:sp>
-      <p:sp>
-        <p:nvSpPr>
-          <p:cNvPr id="6" name="TextBox 5"/>
+          <p:cNvPr id="5" name="TextBox 4"/>
           <p:cNvSpPr txBox="1"/>
           <p:nvPr/>
         </p:nvSpPr>
         <p:spPr>
           <a:xfrm>
-            <a:off x="731520" y="713232"/>
+            <a:off x="731520" y="658368"/>
             <a:ext cx="10728655" cy="502920"/>
           </a:xfrm>
           <a:prstGeom prst="rect">
@@ -3972,28 +3737,28 @@
           <a:lstStyle/>
           <a:p>
             <a:pPr>
-              <a:defRPr b="1" sz="2200">
-                <a:solidFill>
-                  <a:srgbClr val="0A192F"/>
-                </a:solidFill>
-              </a:defRPr>
-            </a:pPr>
-            <a:r>
-              <a:t>THE CHALLENGE: Vulnerabilities in North Eastern Region</a:t>
-            </a:r>
-          </a:p>
-        </p:txBody>
-      </p:sp>
-      <p:sp>
-        <p:nvSpPr>
-          <p:cNvPr id="7" name="TextBox 6"/>
+              <a:defRPr b="1" sz="2100">
+                <a:solidFill>
+                  <a:srgbClr val="1B365D"/>
+                </a:solidFill>
+              </a:defRPr>
+            </a:pPr>
+            <a:r>
+              <a:t>THE CHALLENGE: Critical Vulnerabilities in North Eastern Region</a:t>
+            </a:r>
+          </a:p>
+        </p:txBody>
+      </p:sp>
+      <p:sp>
+        <p:nvSpPr>
+          <p:cNvPr id="6" name="TextBox 5"/>
           <p:cNvSpPr txBox="1"/>
           <p:nvPr/>
         </p:nvSpPr>
         <p:spPr>
           <a:xfrm>
             <a:off x="731520" y="6446520"/>
-            <a:ext cx="8686800" cy="292608"/>
+            <a:ext cx="8686800" cy="274320"/>
           </a:xfrm>
           <a:prstGeom prst="rect">
             <a:avLst/>
@@ -4021,14 +3786,14 @@
       </p:sp>
       <p:sp>
         <p:nvSpPr>
-          <p:cNvPr id="8" name="TextBox 7"/>
+          <p:cNvPr id="7" name="TextBox 6"/>
           <p:cNvSpPr txBox="1"/>
           <p:nvPr/>
         </p:nvSpPr>
         <p:spPr>
           <a:xfrm>
             <a:off x="9601200" y="6446520"/>
-            <a:ext cx="1858975" cy="292608"/>
+            <a:ext cx="1858975" cy="274320"/>
           </a:xfrm>
           <a:prstGeom prst="rect">
             <a:avLst/>
@@ -4044,7 +3809,7 @@
             <a:pPr algn="r">
               <a:defRPr b="1" sz="950">
                 <a:solidFill>
-                  <a:srgbClr val="0A192F"/>
+                  <a:srgbClr val="1B365D"/>
                 </a:solidFill>
               </a:defRPr>
             </a:pPr>
@@ -4056,14 +3821,14 @@
       </p:sp>
       <p:sp>
         <p:nvSpPr>
-          <p:cNvPr id="9" name="Rounded Rectangle 8"/>
+          <p:cNvPr id="8" name="Rounded Rectangle 7"/>
           <p:cNvSpPr/>
           <p:nvPr/>
         </p:nvSpPr>
         <p:spPr>
           <a:xfrm>
-            <a:off x="731520" y="1280160"/>
-            <a:ext cx="10728655" cy="548640"/>
+            <a:off x="731520" y="1234440"/>
+            <a:ext cx="10728655" cy="502920"/>
           </a:xfrm>
           <a:prstGeom prst="roundRect">
             <a:avLst/>
@@ -4096,7 +3861,7 @@
           <a:lstStyle/>
           <a:p>
             <a:pPr algn="ctr">
-              <a:defRPr b="1" sz="1050">
+              <a:defRPr b="1" sz="1000">
                 <a:solidFill>
                   <a:srgbClr val="EF4444"/>
                 </a:solidFill>
@@ -4106,7 +3871,7 @@
               <a:t>PROBLEM SUMMARY: </a:t>
             </a:r>
             <a:r>
-              <a:rPr b="0">
+              <a:rPr sz="950">
                 <a:solidFill>
                   <a:srgbClr val="1E293B"/>
                 </a:solidFill>
@@ -4118,20 +3883,20 @@
       </p:sp>
       <p:sp>
         <p:nvSpPr>
-          <p:cNvPr id="10" name="Rounded Rectangle 9"/>
+          <p:cNvPr id="9" name="Rounded Rectangle 8"/>
           <p:cNvSpPr/>
           <p:nvPr/>
         </p:nvSpPr>
         <p:spPr>
           <a:xfrm>
-            <a:off x="731520" y="1965960"/>
-            <a:ext cx="2542032" cy="2011680"/>
+            <a:off x="731520" y="1874519"/>
+            <a:ext cx="2542032" cy="2057400"/>
           </a:xfrm>
           <a:prstGeom prst="roundRect">
             <a:avLst/>
           </a:prstGeom>
           <a:solidFill>
-            <a:srgbClr val="F8FAFC"/>
+            <a:srgbClr val="FAFAFC"/>
           </a:solidFill>
           <a:ln w="19050">
             <a:solidFill>
@@ -4184,20 +3949,20 @@
       </p:sp>
       <p:sp>
         <p:nvSpPr>
-          <p:cNvPr id="11" name="Rounded Rectangle 10"/>
+          <p:cNvPr id="10" name="Rounded Rectangle 9"/>
           <p:cNvSpPr/>
           <p:nvPr/>
         </p:nvSpPr>
         <p:spPr>
           <a:xfrm>
-            <a:off x="3456432" y="1965960"/>
-            <a:ext cx="2542032" cy="2011680"/>
+            <a:off x="3456432" y="1874519"/>
+            <a:ext cx="2542032" cy="2057400"/>
           </a:xfrm>
           <a:prstGeom prst="roundRect">
             <a:avLst/>
           </a:prstGeom>
           <a:solidFill>
-            <a:srgbClr val="F8FAFC"/>
+            <a:srgbClr val="FAFAFC"/>
           </a:solidFill>
           <a:ln w="19050">
             <a:solidFill>
@@ -4250,20 +4015,20 @@
       </p:sp>
       <p:sp>
         <p:nvSpPr>
-          <p:cNvPr id="12" name="Rounded Rectangle 11"/>
+          <p:cNvPr id="11" name="Rounded Rectangle 10"/>
           <p:cNvSpPr/>
           <p:nvPr/>
         </p:nvSpPr>
         <p:spPr>
           <a:xfrm>
-            <a:off x="6181344" y="1965960"/>
-            <a:ext cx="2542032" cy="2011680"/>
+            <a:off x="6181344" y="1874519"/>
+            <a:ext cx="2542032" cy="2057400"/>
           </a:xfrm>
           <a:prstGeom prst="roundRect">
             <a:avLst/>
           </a:prstGeom>
           <a:solidFill>
-            <a:srgbClr val="F8FAFC"/>
+            <a:srgbClr val="FAFAFC"/>
           </a:solidFill>
           <a:ln w="19050">
             <a:solidFill>
@@ -4316,24 +4081,24 @@
       </p:sp>
       <p:sp>
         <p:nvSpPr>
-          <p:cNvPr id="13" name="Rounded Rectangle 12"/>
+          <p:cNvPr id="12" name="Rounded Rectangle 11"/>
           <p:cNvSpPr/>
           <p:nvPr/>
         </p:nvSpPr>
         <p:spPr>
           <a:xfrm>
-            <a:off x="8906256" y="1965960"/>
-            <a:ext cx="2542032" cy="2011680"/>
+            <a:off x="8906256" y="1874519"/>
+            <a:ext cx="2542032" cy="2057400"/>
           </a:xfrm>
           <a:prstGeom prst="roundRect">
             <a:avLst/>
           </a:prstGeom>
           <a:solidFill>
-            <a:srgbClr val="F8FAFC"/>
+            <a:srgbClr val="FAFAFC"/>
           </a:solidFill>
           <a:ln w="19050">
             <a:solidFill>
-              <a:srgbClr val="0A192F"/>
+              <a:srgbClr val="1B365D"/>
             </a:solidFill>
           </a:ln>
         </p:spPr>
@@ -4358,7 +4123,7 @@
             <a:pPr algn="ctr">
               <a:defRPr b="1" sz="1100">
                 <a:solidFill>
-                  <a:srgbClr val="0A192F"/>
+                  <a:srgbClr val="1B365D"/>
                 </a:solidFill>
               </a:defRPr>
             </a:pPr>
@@ -4375,27 +4140,27 @@
               </a:defRPr>
             </a:pPr>
             <a:r>
-              <a:t>Severe storms knock out mobile towers; authorities receive ground reports hours or days too late.</a:t>
-            </a:r>
-          </a:p>
-        </p:txBody>
-      </p:sp>
-      <p:sp>
-        <p:nvSpPr>
-          <p:cNvPr id="14" name="Rounded Rectangle 13"/>
+              <a:t>Severe storms knock out cell towers; authorities receive ground reports hours or days too late.</a:t>
+            </a:r>
+          </a:p>
+        </p:txBody>
+      </p:sp>
+      <p:sp>
+        <p:nvSpPr>
+          <p:cNvPr id="13" name="Rounded Rectangle 12"/>
           <p:cNvSpPr/>
           <p:nvPr/>
         </p:nvSpPr>
         <p:spPr>
           <a:xfrm>
-            <a:off x="731520" y="4160520"/>
-            <a:ext cx="10728655" cy="2057400"/>
+            <a:off x="731520" y="4114800"/>
+            <a:ext cx="10728655" cy="2148840"/>
           </a:xfrm>
           <a:prstGeom prst="roundRect">
             <a:avLst/>
           </a:prstGeom>
           <a:solidFill>
-            <a:srgbClr val="F8FAFC"/>
+            <a:srgbClr val="FAFAFC"/>
           </a:solidFill>
           <a:ln w="15240">
             <a:solidFill>
@@ -4424,7 +4189,7 @@
             <a:pPr algn="ctr">
               <a:defRPr b="1" sz="1150">
                 <a:solidFill>
-                  <a:srgbClr val="0A192F"/>
+                  <a:srgbClr val="1B365D"/>
                 </a:solidFill>
               </a:defRPr>
             </a:pPr>
@@ -4436,14 +4201,14 @@
       </p:sp>
       <p:sp>
         <p:nvSpPr>
-          <p:cNvPr id="15" name="Rounded Rectangle 14"/>
+          <p:cNvPr id="14" name="Rounded Rectangle 13"/>
           <p:cNvSpPr/>
           <p:nvPr/>
         </p:nvSpPr>
         <p:spPr>
           <a:xfrm>
-            <a:off x="1005840" y="4572000"/>
-            <a:ext cx="4846320" cy="1463040"/>
+            <a:off x="1005840" y="4526280"/>
+            <a:ext cx="4846320" cy="1554480"/>
           </a:xfrm>
           <a:prstGeom prst="roundRect">
             <a:avLst/>
@@ -4490,7 +4255,7 @@
             <a:pPr>
               <a:defRPr b="1" sz="1000">
                 <a:solidFill>
-                  <a:srgbClr val="0A192F"/>
+                  <a:srgbClr val="1B365D"/>
                 </a:solidFill>
               </a:defRPr>
             </a:pPr>
@@ -4514,14 +4279,14 @@
       </p:sp>
       <p:sp>
         <p:nvSpPr>
-          <p:cNvPr id="16" name="Rounded Rectangle 15"/>
+          <p:cNvPr id="15" name="Rounded Rectangle 14"/>
           <p:cNvSpPr/>
           <p:nvPr/>
         </p:nvSpPr>
         <p:spPr>
           <a:xfrm>
-            <a:off x="6217920" y="4572000"/>
-            <a:ext cx="4937760" cy="1463040"/>
+            <a:off x="6217920" y="4526280"/>
+            <a:ext cx="4937760" cy="1554480"/>
           </a:xfrm>
           <a:prstGeom prst="roundRect">
             <a:avLst/>
@@ -4568,7 +4333,7 @@
             <a:pPr>
               <a:defRPr b="1" sz="1000">
                 <a:solidFill>
-                  <a:srgbClr val="0A192F"/>
+                  <a:srgbClr val="1B365D"/>
                 </a:solidFill>
               </a:defRPr>
             </a:pPr>
@@ -4608,12 +4373,20 @@
         <p:nvPr/>
       </p:nvGrpSpPr>
       <p:grpSpPr/>
-      <p:sp>
-        <p:nvSpPr>
-          <p:cNvPr id="2" name="Rectangle 1"/>
-          <p:cNvSpPr/>
+      <p:pic>
+        <p:nvPicPr>
+          <p:cNvPr id="2" name="Picture 1" descr="sih_content_bg.png"/>
+          <p:cNvPicPr>
+            <a:picLocks noChangeAspect="1"/>
+          </p:cNvPicPr>
           <p:nvPr/>
-        </p:nvSpPr>
+        </p:nvPicPr>
+        <p:blipFill>
+          <a:blip r:embed="rId2"/>
+          <a:stretch>
+            <a:fillRect/>
+          </a:stretch>
+        </p:blipFill>
         <p:spPr>
           <a:xfrm>
             <a:off x="0" y="0"/>
@@ -4622,35 +4395,8 @@
           <a:prstGeom prst="rect">
             <a:avLst/>
           </a:prstGeom>
-          <a:solidFill>
-            <a:srgbClr val="FFFFFF"/>
-          </a:solidFill>
-          <a:ln>
-            <a:noFill/>
-          </a:ln>
-        </p:spPr>
-        <p:style>
-          <a:lnRef idx="1">
-            <a:schemeClr val="accent1"/>
-          </a:lnRef>
-          <a:fillRef idx="3">
-            <a:schemeClr val="accent1"/>
-          </a:fillRef>
-          <a:effectRef idx="2">
-            <a:schemeClr val="accent1"/>
-          </a:effectRef>
-          <a:fontRef idx="minor">
-            <a:schemeClr val="lt1"/>
-          </a:fontRef>
-        </p:style>
-        <p:txBody>
-          <a:bodyPr rtlCol="0" anchor="ctr"/>
-          <a:lstStyle/>
-          <a:p>
-            <a:pPr algn="ctr"/>
-          </a:p>
-        </p:txBody>
-      </p:sp>
+        </p:spPr>
+      </p:pic>
       <p:sp>
         <p:nvSpPr>
           <p:cNvPr id="3" name="TextBox 2"/>
@@ -4659,7 +4405,7 @@
         </p:nvSpPr>
         <p:spPr>
           <a:xfrm>
-            <a:off x="731520" y="256032"/>
+            <a:off x="731520" y="228600"/>
             <a:ext cx="4114800" cy="320040"/>
           </a:xfrm>
           <a:prstGeom prst="rect">
@@ -4676,7 +4422,7 @@
             <a:pPr>
               <a:defRPr b="1" sz="1100">
                 <a:solidFill>
-                  <a:srgbClr val="FF6B00"/>
+                  <a:srgbClr val="E65100"/>
                 </a:solidFill>
               </a:defRPr>
             </a:pPr>
@@ -4694,8 +4440,8 @@
         </p:nvSpPr>
         <p:spPr>
           <a:xfrm>
-            <a:off x="6583680" y="256032"/>
-            <a:ext cx="4873752" cy="320040"/>
+            <a:off x="6217920" y="228600"/>
+            <a:ext cx="5242255" cy="320040"/>
           </a:xfrm>
           <a:prstGeom prst="rect">
             <a:avLst/>
@@ -4711,7 +4457,7 @@
             <a:pPr algn="r">
               <a:defRPr b="1" sz="1000">
                 <a:solidFill>
-                  <a:srgbClr val="0A192F"/>
+                  <a:srgbClr val="1B365D"/>
                 </a:solidFill>
               </a:defRPr>
             </a:pPr>
@@ -4723,56 +4469,13 @@
       </p:sp>
       <p:sp>
         <p:nvSpPr>
-          <p:cNvPr id="5" name="Rectangle 4"/>
-          <p:cNvSpPr/>
-          <p:nvPr/>
-        </p:nvSpPr>
-        <p:spPr>
-          <a:xfrm>
-            <a:off x="731520" y="621792"/>
-            <a:ext cx="10728655" cy="18288"/>
-          </a:xfrm>
-          <a:prstGeom prst="rect">
-            <a:avLst/>
-          </a:prstGeom>
-          <a:solidFill>
-            <a:srgbClr val="E2E8F0"/>
-          </a:solidFill>
-          <a:ln>
-            <a:noFill/>
-          </a:ln>
-        </p:spPr>
-        <p:style>
-          <a:lnRef idx="1">
-            <a:schemeClr val="accent1"/>
-          </a:lnRef>
-          <a:fillRef idx="3">
-            <a:schemeClr val="accent1"/>
-          </a:fillRef>
-          <a:effectRef idx="2">
-            <a:schemeClr val="accent1"/>
-          </a:effectRef>
-          <a:fontRef idx="minor">
-            <a:schemeClr val="lt1"/>
-          </a:fontRef>
-        </p:style>
-        <p:txBody>
-          <a:bodyPr rtlCol="0" anchor="ctr"/>
-          <a:lstStyle/>
-          <a:p>
-            <a:pPr algn="ctr"/>
-          </a:p>
-        </p:txBody>
-      </p:sp>
-      <p:sp>
-        <p:nvSpPr>
-          <p:cNvPr id="6" name="TextBox 5"/>
+          <p:cNvPr id="5" name="TextBox 4"/>
           <p:cNvSpPr txBox="1"/>
           <p:nvPr/>
         </p:nvSpPr>
         <p:spPr>
           <a:xfrm>
-            <a:off x="731520" y="713232"/>
+            <a:off x="731520" y="658368"/>
             <a:ext cx="10728655" cy="502920"/>
           </a:xfrm>
           <a:prstGeom prst="rect">
@@ -4787,9 +4490,9 @@
           <a:lstStyle/>
           <a:p>
             <a:pPr>
-              <a:defRPr b="1" sz="2200">
-                <a:solidFill>
-                  <a:srgbClr val="0A192F"/>
+              <a:defRPr b="1" sz="2100">
+                <a:solidFill>
+                  <a:srgbClr val="1B365D"/>
                 </a:solidFill>
               </a:defRPr>
             </a:pPr>
@@ -4801,14 +4504,14 @@
       </p:sp>
       <p:sp>
         <p:nvSpPr>
-          <p:cNvPr id="7" name="TextBox 6"/>
+          <p:cNvPr id="6" name="TextBox 5"/>
           <p:cNvSpPr txBox="1"/>
           <p:nvPr/>
         </p:nvSpPr>
         <p:spPr>
           <a:xfrm>
             <a:off x="731520" y="6446520"/>
-            <a:ext cx="8686800" cy="292608"/>
+            <a:ext cx="8686800" cy="274320"/>
           </a:xfrm>
           <a:prstGeom prst="rect">
             <a:avLst/>
@@ -4836,14 +4539,14 @@
       </p:sp>
       <p:sp>
         <p:nvSpPr>
-          <p:cNvPr id="8" name="TextBox 7"/>
+          <p:cNvPr id="7" name="TextBox 6"/>
           <p:cNvSpPr txBox="1"/>
           <p:nvPr/>
         </p:nvSpPr>
         <p:spPr>
           <a:xfrm>
             <a:off x="9601200" y="6446520"/>
-            <a:ext cx="1858975" cy="292608"/>
+            <a:ext cx="1858975" cy="274320"/>
           </a:xfrm>
           <a:prstGeom prst="rect">
             <a:avLst/>
@@ -4859,7 +4562,7 @@
             <a:pPr algn="r">
               <a:defRPr b="1" sz="950">
                 <a:solidFill>
-                  <a:srgbClr val="0A192F"/>
+                  <a:srgbClr val="1B365D"/>
                 </a:solidFill>
               </a:defRPr>
             </a:pPr>
@@ -4871,20 +4574,20 @@
       </p:sp>
       <p:sp>
         <p:nvSpPr>
-          <p:cNvPr id="9" name="Rounded Rectangle 8"/>
+          <p:cNvPr id="8" name="Rounded Rectangle 7"/>
           <p:cNvSpPr/>
           <p:nvPr/>
         </p:nvSpPr>
         <p:spPr>
           <a:xfrm>
-            <a:off x="731520" y="1280160"/>
-            <a:ext cx="6766560" cy="4937760"/>
+            <a:off x="731520" y="1234440"/>
+            <a:ext cx="6766560" cy="5029200"/>
           </a:xfrm>
           <a:prstGeom prst="roundRect">
             <a:avLst/>
           </a:prstGeom>
           <a:solidFill>
-            <a:srgbClr val="F8FAFC"/>
+            <a:srgbClr val="FAFAFC"/>
           </a:solidFill>
           <a:ln w="15240">
             <a:solidFill>
@@ -4913,7 +4616,7 @@
             <a:pPr algn="ctr">
               <a:defRPr b="1" sz="1200">
                 <a:solidFill>
-                  <a:srgbClr val="0A192F"/>
+                  <a:srgbClr val="1B365D"/>
                 </a:solidFill>
               </a:defRPr>
             </a:pPr>
@@ -4925,7 +4628,7 @@
             <a:pPr>
               <a:defRPr b="1" sz="1019">
                 <a:solidFill>
-                  <a:srgbClr val="FF6B00"/>
+                  <a:srgbClr val="E65100"/>
                 </a:solidFill>
               </a:defRPr>
             </a:pPr>
@@ -4949,7 +4652,7 @@
             <a:pPr>
               <a:defRPr b="1" sz="1019">
                 <a:solidFill>
-                  <a:srgbClr val="0A192F"/>
+                  <a:srgbClr val="1B365D"/>
                 </a:solidFill>
               </a:defRPr>
             </a:pPr>
@@ -5021,20 +4724,20 @@
       </p:sp>
       <p:sp>
         <p:nvSpPr>
-          <p:cNvPr id="10" name="Rounded Rectangle 9"/>
+          <p:cNvPr id="9" name="Rounded Rectangle 8"/>
           <p:cNvSpPr/>
           <p:nvPr/>
         </p:nvSpPr>
         <p:spPr>
           <a:xfrm>
-            <a:off x="7772400" y="1280160"/>
-            <a:ext cx="3687775" cy="4937760"/>
+            <a:off x="7772400" y="1234440"/>
+            <a:ext cx="3687775" cy="5029200"/>
           </a:xfrm>
           <a:prstGeom prst="roundRect">
             <a:avLst/>
           </a:prstGeom>
           <a:solidFill>
-            <a:srgbClr val="F8FAFC"/>
+            <a:srgbClr val="FAFAFC"/>
           </a:solidFill>
           <a:ln w="15240">
             <a:solidFill>
@@ -5063,7 +4766,7 @@
             <a:pPr algn="ctr">
               <a:defRPr b="1" sz="1200">
                 <a:solidFill>
-                  <a:srgbClr val="0A192F"/>
+                  <a:srgbClr val="1B365D"/>
                 </a:solidFill>
               </a:defRPr>
             </a:pPr>
@@ -5187,12 +4890,20 @@
         <p:nvPr/>
       </p:nvGrpSpPr>
       <p:grpSpPr/>
-      <p:sp>
-        <p:nvSpPr>
-          <p:cNvPr id="2" name="Rectangle 1"/>
-          <p:cNvSpPr/>
+      <p:pic>
+        <p:nvPicPr>
+          <p:cNvPr id="2" name="Picture 1" descr="sih_content_bg.png"/>
+          <p:cNvPicPr>
+            <a:picLocks noChangeAspect="1"/>
+          </p:cNvPicPr>
           <p:nvPr/>
-        </p:nvSpPr>
+        </p:nvPicPr>
+        <p:blipFill>
+          <a:blip r:embed="rId2"/>
+          <a:stretch>
+            <a:fillRect/>
+          </a:stretch>
+        </p:blipFill>
         <p:spPr>
           <a:xfrm>
             <a:off x="0" y="0"/>
@@ -5201,11 +4912,204 @@
           <a:prstGeom prst="rect">
             <a:avLst/>
           </a:prstGeom>
+        </p:spPr>
+      </p:pic>
+      <p:sp>
+        <p:nvSpPr>
+          <p:cNvPr id="3" name="TextBox 2"/>
+          <p:cNvSpPr txBox="1"/>
+          <p:nvPr/>
+        </p:nvSpPr>
+        <p:spPr>
+          <a:xfrm>
+            <a:off x="731520" y="228600"/>
+            <a:ext cx="4114800" cy="320040"/>
+          </a:xfrm>
+          <a:prstGeom prst="rect">
+            <a:avLst/>
+          </a:prstGeom>
+          <a:noFill/>
+        </p:spPr>
+        <p:txBody>
+          <a:bodyPr wrap="none">
+            <a:spAutoFit/>
+          </a:bodyPr>
+          <a:lstStyle/>
+          <a:p>
+            <a:pPr>
+              <a:defRPr b="1" sz="1100">
+                <a:solidFill>
+                  <a:srgbClr val="E65100"/>
+                </a:solidFill>
+              </a:defRPr>
+            </a:pPr>
+            <a:r>
+              <a:t>SMART INDIA HACKATHON 2026</a:t>
+            </a:r>
+          </a:p>
+        </p:txBody>
+      </p:sp>
+      <p:sp>
+        <p:nvSpPr>
+          <p:cNvPr id="4" name="TextBox 3"/>
+          <p:cNvSpPr txBox="1"/>
+          <p:nvPr/>
+        </p:nvSpPr>
+        <p:spPr>
+          <a:xfrm>
+            <a:off x="6217920" y="228600"/>
+            <a:ext cx="5242255" cy="320040"/>
+          </a:xfrm>
+          <a:prstGeom prst="rect">
+            <a:avLst/>
+          </a:prstGeom>
+          <a:noFill/>
+        </p:spPr>
+        <p:txBody>
+          <a:bodyPr wrap="none">
+            <a:spAutoFit/>
+          </a:bodyPr>
+          <a:lstStyle/>
+          <a:p>
+            <a:pPr algn="r">
+              <a:defRPr b="1" sz="1000">
+                <a:solidFill>
+                  <a:srgbClr val="1B365D"/>
+                </a:solidFill>
+              </a:defRPr>
+            </a:pPr>
+            <a:r>
+              <a:t>PS ID: SIH26001  |  MDoNER  |  Software Edition</a:t>
+            </a:r>
+          </a:p>
+        </p:txBody>
+      </p:sp>
+      <p:sp>
+        <p:nvSpPr>
+          <p:cNvPr id="5" name="TextBox 4"/>
+          <p:cNvSpPr txBox="1"/>
+          <p:nvPr/>
+        </p:nvSpPr>
+        <p:spPr>
+          <a:xfrm>
+            <a:off x="731520" y="658368"/>
+            <a:ext cx="10728655" cy="502920"/>
+          </a:xfrm>
+          <a:prstGeom prst="rect">
+            <a:avLst/>
+          </a:prstGeom>
+          <a:noFill/>
+        </p:spPr>
+        <p:txBody>
+          <a:bodyPr wrap="none">
+            <a:spAutoFit/>
+          </a:bodyPr>
+          <a:lstStyle/>
+          <a:p>
+            <a:pPr>
+              <a:defRPr b="1" sz="2100">
+                <a:solidFill>
+                  <a:srgbClr val="1B365D"/>
+                </a:solidFill>
+              </a:defRPr>
+            </a:pPr>
+            <a:r>
+              <a:t>KEY INNOVATIONS: Why Team AlertNex Solution is Different</a:t>
+            </a:r>
+          </a:p>
+        </p:txBody>
+      </p:sp>
+      <p:sp>
+        <p:nvSpPr>
+          <p:cNvPr id="6" name="TextBox 5"/>
+          <p:cNvSpPr txBox="1"/>
+          <p:nvPr/>
+        </p:nvSpPr>
+        <p:spPr>
+          <a:xfrm>
+            <a:off x="731520" y="6446520"/>
+            <a:ext cx="8686800" cy="274320"/>
+          </a:xfrm>
+          <a:prstGeom prst="rect">
+            <a:avLst/>
+          </a:prstGeom>
+          <a:noFill/>
+        </p:spPr>
+        <p:txBody>
+          <a:bodyPr wrap="none">
+            <a:spAutoFit/>
+          </a:bodyPr>
+          <a:lstStyle/>
+          <a:p>
+            <a:pPr>
+              <a:defRPr sz="950">
+                <a:solidFill>
+                  <a:srgbClr val="64748B"/>
+                </a:solidFill>
+              </a:defRPr>
+            </a:pPr>
+            <a:r>
+              <a:t>Team AlertNex | Smart India Hackathon 2026 | PS: SIH26001 | Disaster Management</a:t>
+            </a:r>
+          </a:p>
+        </p:txBody>
+      </p:sp>
+      <p:sp>
+        <p:nvSpPr>
+          <p:cNvPr id="7" name="TextBox 6"/>
+          <p:cNvSpPr txBox="1"/>
+          <p:nvPr/>
+        </p:nvSpPr>
+        <p:spPr>
+          <a:xfrm>
+            <a:off x="9601200" y="6446520"/>
+            <a:ext cx="1858975" cy="274320"/>
+          </a:xfrm>
+          <a:prstGeom prst="rect">
+            <a:avLst/>
+          </a:prstGeom>
+          <a:noFill/>
+        </p:spPr>
+        <p:txBody>
+          <a:bodyPr wrap="none">
+            <a:spAutoFit/>
+          </a:bodyPr>
+          <a:lstStyle/>
+          <a:p>
+            <a:pPr algn="r">
+              <a:defRPr b="1" sz="950">
+                <a:solidFill>
+                  <a:srgbClr val="1B365D"/>
+                </a:solidFill>
+              </a:defRPr>
+            </a:pPr>
+            <a:r>
+              <a:t>Slide 4 of 6</a:t>
+            </a:r>
+          </a:p>
+        </p:txBody>
+      </p:sp>
+      <p:sp>
+        <p:nvSpPr>
+          <p:cNvPr id="8" name="Rounded Rectangle 7"/>
+          <p:cNvSpPr/>
+          <p:nvPr/>
+        </p:nvSpPr>
+        <p:spPr>
+          <a:xfrm>
+            <a:off x="731520" y="1234440"/>
+            <a:ext cx="5242255" cy="2450592"/>
+          </a:xfrm>
+          <a:prstGeom prst="roundRect">
+            <a:avLst/>
+          </a:prstGeom>
           <a:solidFill>
-            <a:srgbClr val="FFFFFF"/>
+            <a:srgbClr val="FAFAFC"/>
           </a:solidFill>
-          <a:ln>
-            <a:noFill/>
+          <a:ln w="19050">
+            <a:solidFill>
+              <a:srgbClr val="1B365D"/>
+            </a:solidFill>
           </a:ln>
         </p:spPr>
         <p:style>
@@ -5223,102 +5127,91 @@
           </a:fontRef>
         </p:style>
         <p:txBody>
-          <a:bodyPr rtlCol="0" anchor="ctr"/>
-          <a:lstStyle/>
-          <a:p>
-            <a:pPr algn="ctr"/>
-          </a:p>
-        </p:txBody>
-      </p:sp>
-      <p:sp>
-        <p:nvSpPr>
-          <p:cNvPr id="3" name="TextBox 2"/>
-          <p:cNvSpPr txBox="1"/>
-          <p:nvPr/>
-        </p:nvSpPr>
-        <p:spPr>
-          <a:xfrm>
-            <a:off x="731520" y="256032"/>
-            <a:ext cx="4114800" cy="320040"/>
-          </a:xfrm>
-          <a:prstGeom prst="rect">
-            <a:avLst/>
-          </a:prstGeom>
-          <a:noFill/>
-        </p:spPr>
-        <p:txBody>
-          <a:bodyPr wrap="none">
-            <a:spAutoFit/>
-          </a:bodyPr>
-          <a:lstStyle/>
-          <a:p>
-            <a:pPr>
+          <a:bodyPr rtlCol="0" anchor="ctr" wrap="square" lIns="182880" tIns="109728"/>
+          <a:lstStyle/>
+          <a:p>
+            <a:pPr algn="ctr">
               <a:defRPr b="1" sz="1100">
                 <a:solidFill>
-                  <a:srgbClr val="FF6B00"/>
-                </a:solidFill>
-              </a:defRPr>
-            </a:pPr>
-            <a:r>
-              <a:t>SMART INDIA HACKATHON 2026</a:t>
-            </a:r>
-          </a:p>
-        </p:txBody>
-      </p:sp>
-      <p:sp>
-        <p:nvSpPr>
-          <p:cNvPr id="4" name="TextBox 3"/>
-          <p:cNvSpPr txBox="1"/>
-          <p:nvPr/>
-        </p:nvSpPr>
-        <p:spPr>
-          <a:xfrm>
-            <a:off x="6583680" y="256032"/>
-            <a:ext cx="4873752" cy="320040"/>
-          </a:xfrm>
-          <a:prstGeom prst="rect">
-            <a:avLst/>
-          </a:prstGeom>
-          <a:noFill/>
-        </p:spPr>
-        <p:txBody>
-          <a:bodyPr wrap="none">
-            <a:spAutoFit/>
-          </a:bodyPr>
-          <a:lstStyle/>
-          <a:p>
-            <a:pPr algn="r">
-              <a:defRPr b="1" sz="1000">
-                <a:solidFill>
-                  <a:srgbClr val="0A192F"/>
-                </a:solidFill>
-              </a:defRPr>
-            </a:pPr>
-            <a:r>
-              <a:t>PS ID: SIH26001  |  MDoNER  |  Software Edition</a:t>
-            </a:r>
-          </a:p>
-        </p:txBody>
-      </p:sp>
-      <p:sp>
-        <p:nvSpPr>
-          <p:cNvPr id="5" name="Rectangle 4"/>
+                  <a:srgbClr val="1B365D"/>
+                </a:solidFill>
+              </a:defRPr>
+            </a:pPr>
+            <a:r>
+              <a:t>CARD 1: MULTI-SOURCE AI RISK ANALYSIS</a:t>
+            </a:r>
+          </a:p>
+          <a:p>
+            <a:pPr>
+              <a:defRPr i="1" sz="950">
+                <a:solidFill>
+                  <a:srgbClr val="1B365D"/>
+                </a:solidFill>
+              </a:defRPr>
+            </a:pPr>
+            <a:r>
+              <a:t>Combines Environmental &amp; Ground-Level Information</a:t>
+            </a:r>
+          </a:p>
+          <a:p>
+            <a:pPr>
+              <a:defRPr sz="880">
+                <a:solidFill>
+                  <a:srgbClr val="1E293B"/>
+                </a:solidFill>
+              </a:defRPr>
+            </a:pPr>
+            <a:r>
+              <a:t>• Integrates static terrain data (slope, aspect, elevation) with dynamic live data (rainfall, soil saturation).</a:t>
+            </a:r>
+          </a:p>
+          <a:p>
+            <a:pPr>
+              <a:defRPr sz="880">
+                <a:solidFill>
+                  <a:srgbClr val="1E293B"/>
+                </a:solidFill>
+              </a:defRPr>
+            </a:pPr>
+            <a:r>
+              <a:t>• Fuses satellite imagery with real-time crowdsourced citizen observations.</a:t>
+            </a:r>
+          </a:p>
+          <a:p>
+            <a:pPr>
+              <a:defRPr sz="880">
+                <a:solidFill>
+                  <a:srgbClr val="1E293B"/>
+                </a:solidFill>
+              </a:defRPr>
+            </a:pPr>
+            <a:r>
+              <a:t>• Machine learning ensemble reduces false alarms and avoids alert fatigue.</a:t>
+            </a:r>
+          </a:p>
+        </p:txBody>
+      </p:sp>
+      <p:sp>
+        <p:nvSpPr>
+          <p:cNvPr id="9" name="Rounded Rectangle 8"/>
           <p:cNvSpPr/>
           <p:nvPr/>
         </p:nvSpPr>
         <p:spPr>
           <a:xfrm>
-            <a:off x="731520" y="621792"/>
-            <a:ext cx="10728655" cy="18288"/>
-          </a:xfrm>
-          <a:prstGeom prst="rect">
+            <a:off x="6217920" y="1234440"/>
+            <a:ext cx="5242255" cy="2450592"/>
+          </a:xfrm>
+          <a:prstGeom prst="roundRect">
             <a:avLst/>
           </a:prstGeom>
           <a:solidFill>
-            <a:srgbClr val="E2E8F0"/>
+            <a:srgbClr val="FAFAFC"/>
           </a:solidFill>
-          <a:ln>
-            <a:noFill/>
+          <a:ln w="19050">
+            <a:solidFill>
+              <a:srgbClr val="E65100"/>
+            </a:solidFill>
           </a:ln>
         </p:spPr>
         <p:style>
@@ -5336,350 +5229,98 @@
           </a:fontRef>
         </p:style>
         <p:txBody>
-          <a:bodyPr rtlCol="0" anchor="ctr"/>
-          <a:lstStyle/>
-          <a:p>
-            <a:pPr algn="ctr"/>
-          </a:p>
-        </p:txBody>
-      </p:sp>
-      <p:sp>
-        <p:nvSpPr>
-          <p:cNvPr id="6" name="TextBox 5"/>
-          <p:cNvSpPr txBox="1"/>
-          <p:nvPr/>
-        </p:nvSpPr>
-        <p:spPr>
-          <a:xfrm>
-            <a:off x="731520" y="713232"/>
-            <a:ext cx="10728655" cy="502920"/>
-          </a:xfrm>
-          <a:prstGeom prst="rect">
-            <a:avLst/>
-          </a:prstGeom>
-          <a:noFill/>
-        </p:spPr>
-        <p:txBody>
-          <a:bodyPr wrap="none">
-            <a:spAutoFit/>
-          </a:bodyPr>
-          <a:lstStyle/>
-          <a:p>
-            <a:pPr>
-              <a:defRPr b="1" sz="2200">
-                <a:solidFill>
-                  <a:srgbClr val="0A192F"/>
-                </a:solidFill>
-              </a:defRPr>
-            </a:pPr>
-            <a:r>
-              <a:t>KEY INNOVATIONS: Why Team AlertNex Solution is Different</a:t>
-            </a:r>
-          </a:p>
-        </p:txBody>
-      </p:sp>
-      <p:sp>
-        <p:nvSpPr>
-          <p:cNvPr id="7" name="TextBox 6"/>
-          <p:cNvSpPr txBox="1"/>
-          <p:nvPr/>
-        </p:nvSpPr>
-        <p:spPr>
-          <a:xfrm>
-            <a:off x="731520" y="6446520"/>
-            <a:ext cx="8686800" cy="292608"/>
-          </a:xfrm>
-          <a:prstGeom prst="rect">
-            <a:avLst/>
-          </a:prstGeom>
-          <a:noFill/>
-        </p:spPr>
-        <p:txBody>
-          <a:bodyPr wrap="none">
-            <a:spAutoFit/>
-          </a:bodyPr>
-          <a:lstStyle/>
-          <a:p>
-            <a:pPr>
-              <a:defRPr sz="950">
-                <a:solidFill>
-                  <a:srgbClr val="64748B"/>
-                </a:solidFill>
-              </a:defRPr>
-            </a:pPr>
-            <a:r>
-              <a:t>Team AlertNex | Smart India Hackathon 2026 | PS: SIH26001 | Disaster Management</a:t>
-            </a:r>
-          </a:p>
-        </p:txBody>
-      </p:sp>
-      <p:sp>
-        <p:nvSpPr>
-          <p:cNvPr id="8" name="TextBox 7"/>
-          <p:cNvSpPr txBox="1"/>
-          <p:nvPr/>
-        </p:nvSpPr>
-        <p:spPr>
-          <a:xfrm>
-            <a:off x="9601200" y="6446520"/>
-            <a:ext cx="1858975" cy="292608"/>
-          </a:xfrm>
-          <a:prstGeom prst="rect">
-            <a:avLst/>
-          </a:prstGeom>
-          <a:noFill/>
-        </p:spPr>
-        <p:txBody>
-          <a:bodyPr wrap="none">
-            <a:spAutoFit/>
-          </a:bodyPr>
-          <a:lstStyle/>
-          <a:p>
-            <a:pPr algn="r">
-              <a:defRPr b="1" sz="950">
-                <a:solidFill>
-                  <a:srgbClr val="0A192F"/>
-                </a:solidFill>
-              </a:defRPr>
-            </a:pPr>
-            <a:r>
-              <a:t>Slide 4 of 6</a:t>
-            </a:r>
-          </a:p>
-        </p:txBody>
-      </p:sp>
-      <p:sp>
-        <p:nvSpPr>
-          <p:cNvPr id="9" name="Rounded Rectangle 8"/>
+          <a:bodyPr rtlCol="0" anchor="ctr" wrap="square" lIns="182880" tIns="109728"/>
+          <a:lstStyle/>
+          <a:p>
+            <a:pPr algn="ctr">
+              <a:defRPr b="1" sz="1100">
+                <a:solidFill>
+                  <a:srgbClr val="E65100"/>
+                </a:solidFill>
+              </a:defRPr>
+            </a:pPr>
+            <a:r>
+              <a:t>CARD 2: CONNECTIVITY IMPACT ANALYSIS</a:t>
+            </a:r>
+          </a:p>
+          <a:p>
+            <a:pPr>
+              <a:defRPr i="1" sz="950">
+                <a:solidFill>
+                  <a:srgbClr val="1B365D"/>
+                </a:solidFill>
+              </a:defRPr>
+            </a:pPr>
+            <a:r>
+              <a:t>The Core Innovation: Answering 'What Gets Cut Off?'</a:t>
+            </a:r>
+          </a:p>
+          <a:p>
+            <a:pPr>
+              <a:defRPr sz="880">
+                <a:solidFill>
+                  <a:srgbClr val="1E293B"/>
+                </a:solidFill>
+              </a:defRPr>
+            </a:pPr>
+            <a:r>
+              <a:t>• Road Blockage Analysis: Identifies exact highway segments threatened by impending slides.</a:t>
+            </a:r>
+          </a:p>
+          <a:p>
+            <a:pPr>
+              <a:defRPr sz="880">
+                <a:solidFill>
+                  <a:srgbClr val="1E293B"/>
+                </a:solidFill>
+              </a:defRPr>
+            </a:pPr>
+            <a:r>
+              <a:t>• Village Isolation Analysis: Determines which remote hill villages lose vehicular access.</a:t>
+            </a:r>
+          </a:p>
+          <a:p>
+            <a:pPr>
+              <a:defRPr sz="880">
+                <a:solidFill>
+                  <a:srgbClr val="1E293B"/>
+                </a:solidFill>
+              </a:defRPr>
+            </a:pPr>
+            <a:r>
+              <a:t>• Hospital Accessibility: Analyzes cut-off primary health centers and critical facilities.</a:t>
+            </a:r>
+          </a:p>
+          <a:p>
+            <a:pPr>
+              <a:defRPr sz="880">
+                <a:solidFill>
+                  <a:srgbClr val="1E293B"/>
+                </a:solidFill>
+              </a:defRPr>
+            </a:pPr>
+            <a:r>
+              <a:t>• Alternative Routes: Autonomous graph routing calculates safe bypass emergency corridors.</a:t>
+            </a:r>
+          </a:p>
+        </p:txBody>
+      </p:sp>
+      <p:sp>
+        <p:nvSpPr>
+          <p:cNvPr id="10" name="Rounded Rectangle 9"/>
           <p:cNvSpPr/>
           <p:nvPr/>
         </p:nvSpPr>
         <p:spPr>
           <a:xfrm>
-            <a:off x="731520" y="1280160"/>
-            <a:ext cx="5242255" cy="2423160"/>
+            <a:off x="731520" y="3886200"/>
+            <a:ext cx="5242255" cy="2450592"/>
           </a:xfrm>
           <a:prstGeom prst="roundRect">
             <a:avLst/>
           </a:prstGeom>
           <a:solidFill>
-            <a:srgbClr val="F8FAFC"/>
-          </a:solidFill>
-          <a:ln w="19050">
-            <a:solidFill>
-              <a:srgbClr val="0A192F"/>
-            </a:solidFill>
-          </a:ln>
-        </p:spPr>
-        <p:style>
-          <a:lnRef idx="1">
-            <a:schemeClr val="accent1"/>
-          </a:lnRef>
-          <a:fillRef idx="3">
-            <a:schemeClr val="accent1"/>
-          </a:fillRef>
-          <a:effectRef idx="2">
-            <a:schemeClr val="accent1"/>
-          </a:effectRef>
-          <a:fontRef idx="minor">
-            <a:schemeClr val="lt1"/>
-          </a:fontRef>
-        </p:style>
-        <p:txBody>
-          <a:bodyPr rtlCol="0" anchor="ctr" wrap="square" lIns="182880" tIns="109728"/>
-          <a:lstStyle/>
-          <a:p>
-            <a:pPr algn="ctr">
-              <a:defRPr b="1" sz="1100">
-                <a:solidFill>
-                  <a:srgbClr val="0A192F"/>
-                </a:solidFill>
-              </a:defRPr>
-            </a:pPr>
-            <a:r>
-              <a:t>CARD 1: MULTI-SOURCE AI RISK ANALYSIS</a:t>
-            </a:r>
-          </a:p>
-          <a:p>
-            <a:pPr>
-              <a:defRPr i="1" sz="950">
-                <a:solidFill>
-                  <a:srgbClr val="0A192F"/>
-                </a:solidFill>
-              </a:defRPr>
-            </a:pPr>
-            <a:r>
-              <a:t>Combines Environmental &amp; Ground-Level Information</a:t>
-            </a:r>
-          </a:p>
-          <a:p>
-            <a:pPr>
-              <a:defRPr sz="880">
-                <a:solidFill>
-                  <a:srgbClr val="1E293B"/>
-                </a:solidFill>
-              </a:defRPr>
-            </a:pPr>
-            <a:r>
-              <a:t>• Integrates static terrain data (slope, aspect, elevation) with dynamic live data (rainfall, soil saturation).</a:t>
-            </a:r>
-          </a:p>
-          <a:p>
-            <a:pPr>
-              <a:defRPr sz="880">
-                <a:solidFill>
-                  <a:srgbClr val="1E293B"/>
-                </a:solidFill>
-              </a:defRPr>
-            </a:pPr>
-            <a:r>
-              <a:t>• Fuses satellite imagery with real-time crowdsourced citizen observations.</a:t>
-            </a:r>
-          </a:p>
-          <a:p>
-            <a:pPr>
-              <a:defRPr sz="880">
-                <a:solidFill>
-                  <a:srgbClr val="1E293B"/>
-                </a:solidFill>
-              </a:defRPr>
-            </a:pPr>
-            <a:r>
-              <a:t>• Machine learning ensemble reduces false alarms and avoids alert fatigue.</a:t>
-            </a:r>
-          </a:p>
-        </p:txBody>
-      </p:sp>
-      <p:sp>
-        <p:nvSpPr>
-          <p:cNvPr id="10" name="Rounded Rectangle 9"/>
-          <p:cNvSpPr/>
-          <p:nvPr/>
-        </p:nvSpPr>
-        <p:spPr>
-          <a:xfrm>
-            <a:off x="6217920" y="1280160"/>
-            <a:ext cx="5242255" cy="2423160"/>
-          </a:xfrm>
-          <a:prstGeom prst="roundRect">
-            <a:avLst/>
-          </a:prstGeom>
-          <a:solidFill>
-            <a:srgbClr val="F8FAFC"/>
-          </a:solidFill>
-          <a:ln w="19050">
-            <a:solidFill>
-              <a:srgbClr val="FF6B00"/>
-            </a:solidFill>
-          </a:ln>
-        </p:spPr>
-        <p:style>
-          <a:lnRef idx="1">
-            <a:schemeClr val="accent1"/>
-          </a:lnRef>
-          <a:fillRef idx="3">
-            <a:schemeClr val="accent1"/>
-          </a:fillRef>
-          <a:effectRef idx="2">
-            <a:schemeClr val="accent1"/>
-          </a:effectRef>
-          <a:fontRef idx="minor">
-            <a:schemeClr val="lt1"/>
-          </a:fontRef>
-        </p:style>
-        <p:txBody>
-          <a:bodyPr rtlCol="0" anchor="ctr" wrap="square" lIns="182880" tIns="109728"/>
-          <a:lstStyle/>
-          <a:p>
-            <a:pPr algn="ctr">
-              <a:defRPr b="1" sz="1100">
-                <a:solidFill>
-                  <a:srgbClr val="FF6B00"/>
-                </a:solidFill>
-              </a:defRPr>
-            </a:pPr>
-            <a:r>
-              <a:t>CARD 2: CONNECTIVITY IMPACT ANALYSIS</a:t>
-            </a:r>
-          </a:p>
-          <a:p>
-            <a:pPr>
-              <a:defRPr i="1" sz="950">
-                <a:solidFill>
-                  <a:srgbClr val="0A192F"/>
-                </a:solidFill>
-              </a:defRPr>
-            </a:pPr>
-            <a:r>
-              <a:t>The Core Innovation: Answering 'What Gets Cut Off?'</a:t>
-            </a:r>
-          </a:p>
-          <a:p>
-            <a:pPr>
-              <a:defRPr sz="880">
-                <a:solidFill>
-                  <a:srgbClr val="1E293B"/>
-                </a:solidFill>
-              </a:defRPr>
-            </a:pPr>
-            <a:r>
-              <a:t>• Road Blockage Analysis: Identifies exact highway segments threatened by impending slides.</a:t>
-            </a:r>
-          </a:p>
-          <a:p>
-            <a:pPr>
-              <a:defRPr sz="880">
-                <a:solidFill>
-                  <a:srgbClr val="1E293B"/>
-                </a:solidFill>
-              </a:defRPr>
-            </a:pPr>
-            <a:r>
-              <a:t>• Village Isolation Analysis: Determines which remote hill villages lose vehicular access.</a:t>
-            </a:r>
-          </a:p>
-          <a:p>
-            <a:pPr>
-              <a:defRPr sz="880">
-                <a:solidFill>
-                  <a:srgbClr val="1E293B"/>
-                </a:solidFill>
-              </a:defRPr>
-            </a:pPr>
-            <a:r>
-              <a:t>• Hospital Accessibility: Analyzes cut-off primary health centers and critical facilities.</a:t>
-            </a:r>
-          </a:p>
-          <a:p>
-            <a:pPr>
-              <a:defRPr sz="880">
-                <a:solidFill>
-                  <a:srgbClr val="1E293B"/>
-                </a:solidFill>
-              </a:defRPr>
-            </a:pPr>
-            <a:r>
-              <a:t>• Alternative Routes: Autonomous graph routing calculates safe bypass emergency corridors.</a:t>
-            </a:r>
-          </a:p>
-        </p:txBody>
-      </p:sp>
-      <p:sp>
-        <p:nvSpPr>
-          <p:cNvPr id="11" name="Rounded Rectangle 10"/>
-          <p:cNvSpPr/>
-          <p:nvPr/>
-        </p:nvSpPr>
-        <p:spPr>
-          <a:xfrm>
-            <a:off x="731520" y="3886200"/>
-            <a:ext cx="5242255" cy="2423160"/>
-          </a:xfrm>
-          <a:prstGeom prst="roundRect">
-            <a:avLst/>
-          </a:prstGeom>
-          <a:solidFill>
-            <a:srgbClr val="F8FAFC"/>
+            <a:srgbClr val="FAFAFC"/>
           </a:solidFill>
           <a:ln w="19050">
             <a:solidFill>
@@ -5720,7 +5361,7 @@
             <a:pPr>
               <a:defRPr i="1" sz="950">
                 <a:solidFill>
-                  <a:srgbClr val="0A192F"/>
+                  <a:srgbClr val="1B365D"/>
                 </a:solidFill>
               </a:defRPr>
             </a:pPr>
@@ -5780,20 +5421,20 @@
       </p:sp>
       <p:sp>
         <p:nvSpPr>
-          <p:cNvPr id="12" name="Rounded Rectangle 11"/>
+          <p:cNvPr id="11" name="Rounded Rectangle 10"/>
           <p:cNvSpPr/>
           <p:nvPr/>
         </p:nvSpPr>
         <p:spPr>
           <a:xfrm>
             <a:off x="6217920" y="3886200"/>
-            <a:ext cx="5242255" cy="2423160"/>
+            <a:ext cx="5242255" cy="2450592"/>
           </a:xfrm>
           <a:prstGeom prst="roundRect">
             <a:avLst/>
           </a:prstGeom>
           <a:solidFill>
-            <a:srgbClr val="F8FAFC"/>
+            <a:srgbClr val="FAFAFC"/>
           </a:solidFill>
           <a:ln w="19050">
             <a:solidFill>
@@ -5834,7 +5475,7 @@
             <a:pPr>
               <a:defRPr i="1" sz="950">
                 <a:solidFill>
-                  <a:srgbClr val="0A192F"/>
+                  <a:srgbClr val="1B365D"/>
                 </a:solidFill>
               </a:defRPr>
             </a:pPr>
@@ -5934,12 +5575,20 @@
         <p:nvPr/>
       </p:nvGrpSpPr>
       <p:grpSpPr/>
-      <p:sp>
-        <p:nvSpPr>
-          <p:cNvPr id="2" name="Rectangle 1"/>
-          <p:cNvSpPr/>
+      <p:pic>
+        <p:nvPicPr>
+          <p:cNvPr id="2" name="Picture 1" descr="sih_content_bg.png"/>
+          <p:cNvPicPr>
+            <a:picLocks noChangeAspect="1"/>
+          </p:cNvPicPr>
           <p:nvPr/>
-        </p:nvSpPr>
+        </p:nvPicPr>
+        <p:blipFill>
+          <a:blip r:embed="rId2"/>
+          <a:stretch>
+            <a:fillRect/>
+          </a:stretch>
+        </p:blipFill>
         <p:spPr>
           <a:xfrm>
             <a:off x="0" y="0"/>
@@ -5948,11 +5597,204 @@
           <a:prstGeom prst="rect">
             <a:avLst/>
           </a:prstGeom>
+        </p:spPr>
+      </p:pic>
+      <p:sp>
+        <p:nvSpPr>
+          <p:cNvPr id="3" name="TextBox 2"/>
+          <p:cNvSpPr txBox="1"/>
+          <p:nvPr/>
+        </p:nvSpPr>
+        <p:spPr>
+          <a:xfrm>
+            <a:off x="731520" y="228600"/>
+            <a:ext cx="4114800" cy="320040"/>
+          </a:xfrm>
+          <a:prstGeom prst="rect">
+            <a:avLst/>
+          </a:prstGeom>
+          <a:noFill/>
+        </p:spPr>
+        <p:txBody>
+          <a:bodyPr wrap="none">
+            <a:spAutoFit/>
+          </a:bodyPr>
+          <a:lstStyle/>
+          <a:p>
+            <a:pPr>
+              <a:defRPr b="1" sz="1100">
+                <a:solidFill>
+                  <a:srgbClr val="E65100"/>
+                </a:solidFill>
+              </a:defRPr>
+            </a:pPr>
+            <a:r>
+              <a:t>SMART INDIA HACKATHON 2026</a:t>
+            </a:r>
+          </a:p>
+        </p:txBody>
+      </p:sp>
+      <p:sp>
+        <p:nvSpPr>
+          <p:cNvPr id="4" name="TextBox 3"/>
+          <p:cNvSpPr txBox="1"/>
+          <p:nvPr/>
+        </p:nvSpPr>
+        <p:spPr>
+          <a:xfrm>
+            <a:off x="6217920" y="228600"/>
+            <a:ext cx="5242255" cy="320040"/>
+          </a:xfrm>
+          <a:prstGeom prst="rect">
+            <a:avLst/>
+          </a:prstGeom>
+          <a:noFill/>
+        </p:spPr>
+        <p:txBody>
+          <a:bodyPr wrap="none">
+            <a:spAutoFit/>
+          </a:bodyPr>
+          <a:lstStyle/>
+          <a:p>
+            <a:pPr algn="r">
+              <a:defRPr b="1" sz="1000">
+                <a:solidFill>
+                  <a:srgbClr val="1B365D"/>
+                </a:solidFill>
+              </a:defRPr>
+            </a:pPr>
+            <a:r>
+              <a:t>PS ID: SIH26001  |  MDoNER  |  Software Edition</a:t>
+            </a:r>
+          </a:p>
+        </p:txBody>
+      </p:sp>
+      <p:sp>
+        <p:nvSpPr>
+          <p:cNvPr id="5" name="TextBox 4"/>
+          <p:cNvSpPr txBox="1"/>
+          <p:nvPr/>
+        </p:nvSpPr>
+        <p:spPr>
+          <a:xfrm>
+            <a:off x="731520" y="658368"/>
+            <a:ext cx="10728655" cy="502920"/>
+          </a:xfrm>
+          <a:prstGeom prst="rect">
+            <a:avLst/>
+          </a:prstGeom>
+          <a:noFill/>
+        </p:spPr>
+        <p:txBody>
+          <a:bodyPr wrap="none">
+            <a:spAutoFit/>
+          </a:bodyPr>
+          <a:lstStyle/>
+          <a:p>
+            <a:pPr>
+              <a:defRPr b="1" sz="2100">
+                <a:solidFill>
+                  <a:srgbClr val="1B365D"/>
+                </a:solidFill>
+              </a:defRPr>
+            </a:pPr>
+            <a:r>
+              <a:t>SYSTEM ARCHITECTURE: 4-Tier Flow &amp; Technology Stack</a:t>
+            </a:r>
+          </a:p>
+        </p:txBody>
+      </p:sp>
+      <p:sp>
+        <p:nvSpPr>
+          <p:cNvPr id="6" name="TextBox 5"/>
+          <p:cNvSpPr txBox="1"/>
+          <p:nvPr/>
+        </p:nvSpPr>
+        <p:spPr>
+          <a:xfrm>
+            <a:off x="731520" y="6446520"/>
+            <a:ext cx="8686800" cy="274320"/>
+          </a:xfrm>
+          <a:prstGeom prst="rect">
+            <a:avLst/>
+          </a:prstGeom>
+          <a:noFill/>
+        </p:spPr>
+        <p:txBody>
+          <a:bodyPr wrap="none">
+            <a:spAutoFit/>
+          </a:bodyPr>
+          <a:lstStyle/>
+          <a:p>
+            <a:pPr>
+              <a:defRPr sz="950">
+                <a:solidFill>
+                  <a:srgbClr val="64748B"/>
+                </a:solidFill>
+              </a:defRPr>
+            </a:pPr>
+            <a:r>
+              <a:t>Team AlertNex | Smart India Hackathon 2026 | PS: SIH26001 | Disaster Management</a:t>
+            </a:r>
+          </a:p>
+        </p:txBody>
+      </p:sp>
+      <p:sp>
+        <p:nvSpPr>
+          <p:cNvPr id="7" name="TextBox 6"/>
+          <p:cNvSpPr txBox="1"/>
+          <p:nvPr/>
+        </p:nvSpPr>
+        <p:spPr>
+          <a:xfrm>
+            <a:off x="9601200" y="6446520"/>
+            <a:ext cx="1858975" cy="274320"/>
+          </a:xfrm>
+          <a:prstGeom prst="rect">
+            <a:avLst/>
+          </a:prstGeom>
+          <a:noFill/>
+        </p:spPr>
+        <p:txBody>
+          <a:bodyPr wrap="none">
+            <a:spAutoFit/>
+          </a:bodyPr>
+          <a:lstStyle/>
+          <a:p>
+            <a:pPr algn="r">
+              <a:defRPr b="1" sz="950">
+                <a:solidFill>
+                  <a:srgbClr val="1B365D"/>
+                </a:solidFill>
+              </a:defRPr>
+            </a:pPr>
+            <a:r>
+              <a:t>Slide 5 of 6</a:t>
+            </a:r>
+          </a:p>
+        </p:txBody>
+      </p:sp>
+      <p:sp>
+        <p:nvSpPr>
+          <p:cNvPr id="8" name="Rounded Rectangle 7"/>
+          <p:cNvSpPr/>
+          <p:nvPr/>
+        </p:nvSpPr>
+        <p:spPr>
+          <a:xfrm>
+            <a:off x="731520" y="1234440"/>
+            <a:ext cx="10728655" cy="914400"/>
+          </a:xfrm>
+          <a:prstGeom prst="roundRect">
+            <a:avLst/>
+          </a:prstGeom>
           <a:solidFill>
-            <a:srgbClr val="FFFFFF"/>
+            <a:srgbClr val="FAFAFC"/>
           </a:solidFill>
-          <a:ln>
-            <a:noFill/>
+          <a:ln w="19050">
+            <a:solidFill>
+              <a:srgbClr val="E65100"/>
+            </a:solidFill>
           </a:ln>
         </p:spPr>
         <p:style>
@@ -5970,102 +5812,55 @@
           </a:fontRef>
         </p:style>
         <p:txBody>
-          <a:bodyPr rtlCol="0" anchor="ctr"/>
-          <a:lstStyle/>
-          <a:p>
-            <a:pPr algn="ctr"/>
-          </a:p>
-        </p:txBody>
-      </p:sp>
-      <p:sp>
-        <p:nvSpPr>
-          <p:cNvPr id="3" name="TextBox 2"/>
-          <p:cNvSpPr txBox="1"/>
-          <p:nvPr/>
-        </p:nvSpPr>
-        <p:spPr>
-          <a:xfrm>
-            <a:off x="731520" y="256032"/>
-            <a:ext cx="4114800" cy="320040"/>
-          </a:xfrm>
-          <a:prstGeom prst="rect">
-            <a:avLst/>
-          </a:prstGeom>
-          <a:noFill/>
-        </p:spPr>
-        <p:txBody>
-          <a:bodyPr wrap="none">
-            <a:spAutoFit/>
-          </a:bodyPr>
-          <a:lstStyle/>
-          <a:p>
-            <a:pPr>
+          <a:bodyPr rtlCol="0" anchor="ctr" wrap="square" lIns="182880" tIns="91440"/>
+          <a:lstStyle/>
+          <a:p>
+            <a:pPr algn="ctr">
               <a:defRPr b="1" sz="1100">
                 <a:solidFill>
-                  <a:srgbClr val="FF6B00"/>
-                </a:solidFill>
-              </a:defRPr>
-            </a:pPr>
-            <a:r>
-              <a:t>SMART INDIA HACKATHON 2026</a:t>
-            </a:r>
-          </a:p>
-        </p:txBody>
-      </p:sp>
-      <p:sp>
-        <p:nvSpPr>
-          <p:cNvPr id="4" name="TextBox 3"/>
-          <p:cNvSpPr txBox="1"/>
-          <p:nvPr/>
-        </p:nvSpPr>
-        <p:spPr>
-          <a:xfrm>
-            <a:off x="6583680" y="256032"/>
-            <a:ext cx="4873752" cy="320040"/>
-          </a:xfrm>
-          <a:prstGeom prst="rect">
-            <a:avLst/>
-          </a:prstGeom>
-          <a:noFill/>
-        </p:spPr>
-        <p:txBody>
-          <a:bodyPr wrap="none">
-            <a:spAutoFit/>
-          </a:bodyPr>
-          <a:lstStyle/>
-          <a:p>
-            <a:pPr algn="r">
-              <a:defRPr b="1" sz="1000">
-                <a:solidFill>
-                  <a:srgbClr val="0A192F"/>
-                </a:solidFill>
-              </a:defRPr>
-            </a:pPr>
-            <a:r>
-              <a:t>PS ID: SIH26001  |  MDoNER  |  Software Edition</a:t>
-            </a:r>
-          </a:p>
-        </p:txBody>
-      </p:sp>
-      <p:sp>
-        <p:nvSpPr>
-          <p:cNvPr id="5" name="Rectangle 4"/>
+                  <a:srgbClr val="E65100"/>
+                </a:solidFill>
+              </a:defRPr>
+            </a:pPr>
+            <a:r>
+              <a:t>LAYER 1: DATA COLLECTION</a:t>
+            </a:r>
+          </a:p>
+          <a:p>
+            <a:pPr>
+              <a:defRPr sz="919">
+                <a:solidFill>
+                  <a:srgbClr val="1E293B"/>
+                </a:solidFill>
+              </a:defRPr>
+            </a:pPr>
+            <a:r>
+              <a:t>Weather &amp; Rainfall (IMD API, GPM) • Soil Moisture (NASA SMAP) • Terrain &amp; Elevation (SRTM 30m DEM) • Satellite Data (Sentinel-2) • Citizen &amp; Field Officer Reports</a:t>
+            </a:r>
+          </a:p>
+        </p:txBody>
+      </p:sp>
+      <p:sp>
+        <p:nvSpPr>
+          <p:cNvPr id="9" name="Rounded Rectangle 8"/>
           <p:cNvSpPr/>
           <p:nvPr/>
         </p:nvSpPr>
         <p:spPr>
           <a:xfrm>
-            <a:off x="731520" y="621792"/>
-            <a:ext cx="10728655" cy="18288"/>
-          </a:xfrm>
-          <a:prstGeom prst="rect">
+            <a:off x="731520" y="2286000"/>
+            <a:ext cx="10728655" cy="914400"/>
+          </a:xfrm>
+          <a:prstGeom prst="roundRect">
             <a:avLst/>
           </a:prstGeom>
           <a:solidFill>
-            <a:srgbClr val="E2E8F0"/>
+            <a:srgbClr val="FAFAFC"/>
           </a:solidFill>
-          <a:ln>
-            <a:noFill/>
+          <a:ln w="19050">
+            <a:solidFill>
+              <a:srgbClr val="1B365D"/>
+            </a:solidFill>
           </a:ln>
         </p:spPr>
         <p:style>
@@ -6083,266 +5878,50 @@
           </a:fontRef>
         </p:style>
         <p:txBody>
-          <a:bodyPr rtlCol="0" anchor="ctr"/>
-          <a:lstStyle/>
-          <a:p>
-            <a:pPr algn="ctr"/>
-          </a:p>
-        </p:txBody>
-      </p:sp>
-      <p:sp>
-        <p:nvSpPr>
-          <p:cNvPr id="6" name="TextBox 5"/>
-          <p:cNvSpPr txBox="1"/>
-          <p:nvPr/>
-        </p:nvSpPr>
-        <p:spPr>
-          <a:xfrm>
-            <a:off x="731520" y="713232"/>
-            <a:ext cx="10728655" cy="502920"/>
-          </a:xfrm>
-          <a:prstGeom prst="rect">
-            <a:avLst/>
-          </a:prstGeom>
-          <a:noFill/>
-        </p:spPr>
-        <p:txBody>
-          <a:bodyPr wrap="none">
-            <a:spAutoFit/>
-          </a:bodyPr>
-          <a:lstStyle/>
-          <a:p>
-            <a:pPr>
-              <a:defRPr b="1" sz="2200">
-                <a:solidFill>
-                  <a:srgbClr val="0A192F"/>
-                </a:solidFill>
-              </a:defRPr>
-            </a:pPr>
-            <a:r>
-              <a:t>SYSTEM ARCHITECTURE: 4-Tier Flow &amp; Technology Stack</a:t>
-            </a:r>
-          </a:p>
-        </p:txBody>
-      </p:sp>
-      <p:sp>
-        <p:nvSpPr>
-          <p:cNvPr id="7" name="TextBox 6"/>
-          <p:cNvSpPr txBox="1"/>
-          <p:nvPr/>
-        </p:nvSpPr>
-        <p:spPr>
-          <a:xfrm>
-            <a:off x="731520" y="6446520"/>
-            <a:ext cx="8686800" cy="292608"/>
-          </a:xfrm>
-          <a:prstGeom prst="rect">
-            <a:avLst/>
-          </a:prstGeom>
-          <a:noFill/>
-        </p:spPr>
-        <p:txBody>
-          <a:bodyPr wrap="none">
-            <a:spAutoFit/>
-          </a:bodyPr>
-          <a:lstStyle/>
-          <a:p>
-            <a:pPr>
-              <a:defRPr sz="950">
-                <a:solidFill>
-                  <a:srgbClr val="64748B"/>
-                </a:solidFill>
-              </a:defRPr>
-            </a:pPr>
-            <a:r>
-              <a:t>Team AlertNex | Smart India Hackathon 2026 | PS: SIH26001 | Disaster Management</a:t>
-            </a:r>
-          </a:p>
-        </p:txBody>
-      </p:sp>
-      <p:sp>
-        <p:nvSpPr>
-          <p:cNvPr id="8" name="TextBox 7"/>
-          <p:cNvSpPr txBox="1"/>
-          <p:nvPr/>
-        </p:nvSpPr>
-        <p:spPr>
-          <a:xfrm>
-            <a:off x="9601200" y="6446520"/>
-            <a:ext cx="1858975" cy="292608"/>
-          </a:xfrm>
-          <a:prstGeom prst="rect">
-            <a:avLst/>
-          </a:prstGeom>
-          <a:noFill/>
-        </p:spPr>
-        <p:txBody>
-          <a:bodyPr wrap="none">
-            <a:spAutoFit/>
-          </a:bodyPr>
-          <a:lstStyle/>
-          <a:p>
-            <a:pPr algn="r">
-              <a:defRPr b="1" sz="950">
-                <a:solidFill>
-                  <a:srgbClr val="0A192F"/>
-                </a:solidFill>
-              </a:defRPr>
-            </a:pPr>
-            <a:r>
-              <a:t>Slide 5 of 6</a:t>
-            </a:r>
-          </a:p>
-        </p:txBody>
-      </p:sp>
-      <p:sp>
-        <p:nvSpPr>
-          <p:cNvPr id="9" name="Rounded Rectangle 8"/>
+          <a:bodyPr rtlCol="0" anchor="ctr" wrap="square" lIns="182880" tIns="91440"/>
+          <a:lstStyle/>
+          <a:p>
+            <a:pPr algn="ctr">
+              <a:defRPr b="1" sz="1100">
+                <a:solidFill>
+                  <a:srgbClr val="1B365D"/>
+                </a:solidFill>
+              </a:defRPr>
+            </a:pPr>
+            <a:r>
+              <a:t>LAYER 2: AI AND ANALYTICS ENGINE</a:t>
+            </a:r>
+          </a:p>
+          <a:p>
+            <a:pPr>
+              <a:defRPr sz="919">
+                <a:solidFill>
+                  <a:srgbClr val="1E293B"/>
+                </a:solidFill>
+              </a:defRPr>
+            </a:pPr>
+            <a:r>
+              <a:t>Data Processing (Pandas, NumPy) • Machine Learning Risk Analysis (Scikit-learn, XGBoost) • Explainable AI Module (SHAP Factor Breakdown)</a:t>
+            </a:r>
+          </a:p>
+        </p:txBody>
+      </p:sp>
+      <p:sp>
+        <p:nvSpPr>
+          <p:cNvPr id="10" name="Rounded Rectangle 9"/>
           <p:cNvSpPr/>
           <p:nvPr/>
         </p:nvSpPr>
         <p:spPr>
           <a:xfrm>
-            <a:off x="731520" y="1280160"/>
+            <a:off x="731520" y="3337560"/>
             <a:ext cx="10728655" cy="914400"/>
           </a:xfrm>
           <a:prstGeom prst="roundRect">
             <a:avLst/>
           </a:prstGeom>
           <a:solidFill>
-            <a:srgbClr val="F8FAFC"/>
-          </a:solidFill>
-          <a:ln w="19050">
-            <a:solidFill>
-              <a:srgbClr val="FF6B00"/>
-            </a:solidFill>
-          </a:ln>
-        </p:spPr>
-        <p:style>
-          <a:lnRef idx="1">
-            <a:schemeClr val="accent1"/>
-          </a:lnRef>
-          <a:fillRef idx="3">
-            <a:schemeClr val="accent1"/>
-          </a:fillRef>
-          <a:effectRef idx="2">
-            <a:schemeClr val="accent1"/>
-          </a:effectRef>
-          <a:fontRef idx="minor">
-            <a:schemeClr val="lt1"/>
-          </a:fontRef>
-        </p:style>
-        <p:txBody>
-          <a:bodyPr rtlCol="0" anchor="ctr" wrap="square" lIns="182880" tIns="91440"/>
-          <a:lstStyle/>
-          <a:p>
-            <a:pPr algn="ctr">
-              <a:defRPr b="1" sz="1100">
-                <a:solidFill>
-                  <a:srgbClr val="FF6B00"/>
-                </a:solidFill>
-              </a:defRPr>
-            </a:pPr>
-            <a:r>
-              <a:t>LAYER 1: DATA COLLECTION</a:t>
-            </a:r>
-          </a:p>
-          <a:p>
-            <a:pPr>
-              <a:defRPr sz="919">
-                <a:solidFill>
-                  <a:srgbClr val="1E293B"/>
-                </a:solidFill>
-              </a:defRPr>
-            </a:pPr>
-            <a:r>
-              <a:t>Weather &amp; Rainfall (IMD API, GPM) • Soil Moisture (NASA SMAP) • Terrain &amp; Elevation (SRTM 30m DEM) • Satellite Data (Sentinel-2) • Citizen &amp; Field Officer Reports</a:t>
-            </a:r>
-          </a:p>
-        </p:txBody>
-      </p:sp>
-      <p:sp>
-        <p:nvSpPr>
-          <p:cNvPr id="10" name="Rounded Rectangle 9"/>
-          <p:cNvSpPr/>
-          <p:nvPr/>
-        </p:nvSpPr>
-        <p:spPr>
-          <a:xfrm>
-            <a:off x="731520" y="2331720"/>
-            <a:ext cx="10728655" cy="914400"/>
-          </a:xfrm>
-          <a:prstGeom prst="roundRect">
-            <a:avLst/>
-          </a:prstGeom>
-          <a:solidFill>
-            <a:srgbClr val="F8FAFC"/>
-          </a:solidFill>
-          <a:ln w="19050">
-            <a:solidFill>
-              <a:srgbClr val="0A192F"/>
-            </a:solidFill>
-          </a:ln>
-        </p:spPr>
-        <p:style>
-          <a:lnRef idx="1">
-            <a:schemeClr val="accent1"/>
-          </a:lnRef>
-          <a:fillRef idx="3">
-            <a:schemeClr val="accent1"/>
-          </a:fillRef>
-          <a:effectRef idx="2">
-            <a:schemeClr val="accent1"/>
-          </a:effectRef>
-          <a:fontRef idx="minor">
-            <a:schemeClr val="lt1"/>
-          </a:fontRef>
-        </p:style>
-        <p:txBody>
-          <a:bodyPr rtlCol="0" anchor="ctr" wrap="square" lIns="182880" tIns="91440"/>
-          <a:lstStyle/>
-          <a:p>
-            <a:pPr algn="ctr">
-              <a:defRPr b="1" sz="1100">
-                <a:solidFill>
-                  <a:srgbClr val="0A192F"/>
-                </a:solidFill>
-              </a:defRPr>
-            </a:pPr>
-            <a:r>
-              <a:t>LAYER 2: AI AND ANALYTICS ENGINE</a:t>
-            </a:r>
-          </a:p>
-          <a:p>
-            <a:pPr>
-              <a:defRPr sz="919">
-                <a:solidFill>
-                  <a:srgbClr val="1E293B"/>
-                </a:solidFill>
-              </a:defRPr>
-            </a:pPr>
-            <a:r>
-              <a:t>Data Processing (Pandas, NumPy) • Machine Learning Risk Analysis (Scikit-learn, XGBoost) • Explainable AI Module (SHAP Factor Breakdown)</a:t>
-            </a:r>
-          </a:p>
-        </p:txBody>
-      </p:sp>
-      <p:sp>
-        <p:nvSpPr>
-          <p:cNvPr id="11" name="Rounded Rectangle 10"/>
-          <p:cNvSpPr/>
-          <p:nvPr/>
-        </p:nvSpPr>
-        <p:spPr>
-          <a:xfrm>
-            <a:off x="731520" y="3383279"/>
-            <a:ext cx="10728655" cy="914400"/>
-          </a:xfrm>
-          <a:prstGeom prst="roundRect">
-            <a:avLst/>
-          </a:prstGeom>
-          <a:solidFill>
-            <a:srgbClr val="F8FAFC"/>
+            <a:srgbClr val="FAFAFC"/>
           </a:solidFill>
           <a:ln w="19050">
             <a:solidFill>
@@ -6395,20 +5974,20 @@
       </p:sp>
       <p:sp>
         <p:nvSpPr>
-          <p:cNvPr id="12" name="Rounded Rectangle 11"/>
+          <p:cNvPr id="11" name="Rounded Rectangle 10"/>
           <p:cNvSpPr/>
           <p:nvPr/>
         </p:nvSpPr>
         <p:spPr>
           <a:xfrm>
-            <a:off x="731520" y="4434840"/>
+            <a:off x="731520" y="4389120"/>
             <a:ext cx="10728655" cy="914400"/>
           </a:xfrm>
           <a:prstGeom prst="roundRect">
             <a:avLst/>
           </a:prstGeom>
           <a:solidFill>
-            <a:srgbClr val="F8FAFC"/>
+            <a:srgbClr val="FAFAFC"/>
           </a:solidFill>
           <a:ln w="19050">
             <a:solidFill>
@@ -6461,7 +6040,7 @@
       </p:sp>
       <p:sp>
         <p:nvSpPr>
-          <p:cNvPr id="13" name="Rounded Rectangle 12"/>
+          <p:cNvPr id="12" name="Rounded Rectangle 11"/>
           <p:cNvSpPr/>
           <p:nvPr/>
         </p:nvSpPr>
@@ -6478,7 +6057,7 @@
           </a:solidFill>
           <a:ln w="12700">
             <a:solidFill>
-              <a:srgbClr val="0A192F"/>
+              <a:srgbClr val="1B365D"/>
             </a:solidFill>
           </a:ln>
         </p:spPr>
@@ -6543,12 +6122,20 @@
         <p:nvPr/>
       </p:nvGrpSpPr>
       <p:grpSpPr/>
-      <p:sp>
-        <p:nvSpPr>
-          <p:cNvPr id="2" name="Rectangle 1"/>
-          <p:cNvSpPr/>
+      <p:pic>
+        <p:nvPicPr>
+          <p:cNvPr id="2" name="Picture 1" descr="sih_content_bg.png"/>
+          <p:cNvPicPr>
+            <a:picLocks noChangeAspect="1"/>
+          </p:cNvPicPr>
           <p:nvPr/>
-        </p:nvSpPr>
+        </p:nvPicPr>
+        <p:blipFill>
+          <a:blip r:embed="rId2"/>
+          <a:stretch>
+            <a:fillRect/>
+          </a:stretch>
+        </p:blipFill>
         <p:spPr>
           <a:xfrm>
             <a:off x="0" y="0"/>
@@ -6557,35 +6144,8 @@
           <a:prstGeom prst="rect">
             <a:avLst/>
           </a:prstGeom>
-          <a:solidFill>
-            <a:srgbClr val="FFFFFF"/>
-          </a:solidFill>
-          <a:ln>
-            <a:noFill/>
-          </a:ln>
-        </p:spPr>
-        <p:style>
-          <a:lnRef idx="1">
-            <a:schemeClr val="accent1"/>
-          </a:lnRef>
-          <a:fillRef idx="3">
-            <a:schemeClr val="accent1"/>
-          </a:fillRef>
-          <a:effectRef idx="2">
-            <a:schemeClr val="accent1"/>
-          </a:effectRef>
-          <a:fontRef idx="minor">
-            <a:schemeClr val="lt1"/>
-          </a:fontRef>
-        </p:style>
-        <p:txBody>
-          <a:bodyPr rtlCol="0" anchor="ctr"/>
-          <a:lstStyle/>
-          <a:p>
-            <a:pPr algn="ctr"/>
-          </a:p>
-        </p:txBody>
-      </p:sp>
+        </p:spPr>
+      </p:pic>
       <p:sp>
         <p:nvSpPr>
           <p:cNvPr id="3" name="TextBox 2"/>
@@ -6594,7 +6154,7 @@
         </p:nvSpPr>
         <p:spPr>
           <a:xfrm>
-            <a:off x="731520" y="256032"/>
+            <a:off x="731520" y="228600"/>
             <a:ext cx="4114800" cy="320040"/>
           </a:xfrm>
           <a:prstGeom prst="rect">
@@ -6611,7 +6171,7 @@
             <a:pPr>
               <a:defRPr b="1" sz="1100">
                 <a:solidFill>
-                  <a:srgbClr val="FF6B00"/>
+                  <a:srgbClr val="E65100"/>
                 </a:solidFill>
               </a:defRPr>
             </a:pPr>
@@ -6629,8 +6189,8 @@
         </p:nvSpPr>
         <p:spPr>
           <a:xfrm>
-            <a:off x="6583680" y="256032"/>
-            <a:ext cx="4873752" cy="320040"/>
+            <a:off x="6217920" y="228600"/>
+            <a:ext cx="5242255" cy="320040"/>
           </a:xfrm>
           <a:prstGeom prst="rect">
             <a:avLst/>
@@ -6646,7 +6206,7 @@
             <a:pPr algn="r">
               <a:defRPr b="1" sz="1000">
                 <a:solidFill>
-                  <a:srgbClr val="0A192F"/>
+                  <a:srgbClr val="1B365D"/>
                 </a:solidFill>
               </a:defRPr>
             </a:pPr>
@@ -6658,56 +6218,13 @@
       </p:sp>
       <p:sp>
         <p:nvSpPr>
-          <p:cNvPr id="5" name="Rectangle 4"/>
-          <p:cNvSpPr/>
-          <p:nvPr/>
-        </p:nvSpPr>
-        <p:spPr>
-          <a:xfrm>
-            <a:off x="731520" y="621792"/>
-            <a:ext cx="10728655" cy="18288"/>
-          </a:xfrm>
-          <a:prstGeom prst="rect">
-            <a:avLst/>
-          </a:prstGeom>
-          <a:solidFill>
-            <a:srgbClr val="E2E8F0"/>
-          </a:solidFill>
-          <a:ln>
-            <a:noFill/>
-          </a:ln>
-        </p:spPr>
-        <p:style>
-          <a:lnRef idx="1">
-            <a:schemeClr val="accent1"/>
-          </a:lnRef>
-          <a:fillRef idx="3">
-            <a:schemeClr val="accent1"/>
-          </a:fillRef>
-          <a:effectRef idx="2">
-            <a:schemeClr val="accent1"/>
-          </a:effectRef>
-          <a:fontRef idx="minor">
-            <a:schemeClr val="lt1"/>
-          </a:fontRef>
-        </p:style>
-        <p:txBody>
-          <a:bodyPr rtlCol="0" anchor="ctr"/>
-          <a:lstStyle/>
-          <a:p>
-            <a:pPr algn="ctr"/>
-          </a:p>
-        </p:txBody>
-      </p:sp>
-      <p:sp>
-        <p:nvSpPr>
-          <p:cNvPr id="6" name="TextBox 5"/>
+          <p:cNvPr id="5" name="TextBox 4"/>
           <p:cNvSpPr txBox="1"/>
           <p:nvPr/>
         </p:nvSpPr>
         <p:spPr>
           <a:xfrm>
-            <a:off x="731520" y="713232"/>
+            <a:off x="731520" y="658368"/>
             <a:ext cx="10728655" cy="502920"/>
           </a:xfrm>
           <a:prstGeom prst="rect">
@@ -6722,9 +6239,9 @@
           <a:lstStyle/>
           <a:p>
             <a:pPr>
-              <a:defRPr b="1" sz="2200">
-                <a:solidFill>
-                  <a:srgbClr val="0A192F"/>
+              <a:defRPr b="1" sz="2100">
+                <a:solidFill>
+                  <a:srgbClr val="1B365D"/>
                 </a:solidFill>
               </a:defRPr>
             </a:pPr>
@@ -6736,14 +6253,14 @@
       </p:sp>
       <p:sp>
         <p:nvSpPr>
-          <p:cNvPr id="7" name="TextBox 6"/>
+          <p:cNvPr id="6" name="TextBox 5"/>
           <p:cNvSpPr txBox="1"/>
           <p:nvPr/>
         </p:nvSpPr>
         <p:spPr>
           <a:xfrm>
             <a:off x="731520" y="6446520"/>
-            <a:ext cx="8686800" cy="292608"/>
+            <a:ext cx="8686800" cy="274320"/>
           </a:xfrm>
           <a:prstGeom prst="rect">
             <a:avLst/>
@@ -6771,14 +6288,14 @@
       </p:sp>
       <p:sp>
         <p:nvSpPr>
-          <p:cNvPr id="8" name="TextBox 7"/>
+          <p:cNvPr id="7" name="TextBox 6"/>
           <p:cNvSpPr txBox="1"/>
           <p:nvPr/>
         </p:nvSpPr>
         <p:spPr>
           <a:xfrm>
             <a:off x="9601200" y="6446520"/>
-            <a:ext cx="1858975" cy="292608"/>
+            <a:ext cx="1858975" cy="274320"/>
           </a:xfrm>
           <a:prstGeom prst="rect">
             <a:avLst/>
@@ -6794,7 +6311,7 @@
             <a:pPr algn="r">
               <a:defRPr b="1" sz="950">
                 <a:solidFill>
-                  <a:srgbClr val="0A192F"/>
+                  <a:srgbClr val="1B365D"/>
                 </a:solidFill>
               </a:defRPr>
             </a:pPr>
@@ -6806,20 +6323,20 @@
       </p:sp>
       <p:sp>
         <p:nvSpPr>
-          <p:cNvPr id="9" name="Rounded Rectangle 8"/>
+          <p:cNvPr id="8" name="Rounded Rectangle 7"/>
           <p:cNvSpPr/>
           <p:nvPr/>
         </p:nvSpPr>
         <p:spPr>
           <a:xfrm>
-            <a:off x="731520" y="1280160"/>
-            <a:ext cx="3474720" cy="4206240"/>
+            <a:off x="731520" y="1234440"/>
+            <a:ext cx="3474720" cy="4251960"/>
           </a:xfrm>
           <a:prstGeom prst="roundRect">
             <a:avLst/>
           </a:prstGeom>
           <a:solidFill>
-            <a:srgbClr val="F8FAFC"/>
+            <a:srgbClr val="FAFAFC"/>
           </a:solidFill>
           <a:ln w="19050">
             <a:solidFill>
@@ -6932,24 +6449,24 @@
       </p:sp>
       <p:sp>
         <p:nvSpPr>
-          <p:cNvPr id="10" name="Rounded Rectangle 9"/>
+          <p:cNvPr id="9" name="Rounded Rectangle 8"/>
           <p:cNvSpPr/>
           <p:nvPr/>
         </p:nvSpPr>
         <p:spPr>
           <a:xfrm>
-            <a:off x="4343400" y="1280160"/>
-            <a:ext cx="3474720" cy="4206240"/>
+            <a:off x="4343400" y="1234440"/>
+            <a:ext cx="3474720" cy="4251960"/>
           </a:xfrm>
           <a:prstGeom prst="roundRect">
             <a:avLst/>
           </a:prstGeom>
           <a:solidFill>
-            <a:srgbClr val="F8FAFC"/>
+            <a:srgbClr val="FAFAFC"/>
           </a:solidFill>
           <a:ln w="19050">
             <a:solidFill>
-              <a:srgbClr val="0A192F"/>
+              <a:srgbClr val="1B365D"/>
             </a:solidFill>
           </a:ln>
         </p:spPr>
@@ -6974,7 +6491,7 @@
             <a:pPr algn="ctr">
               <a:defRPr b="1" sz="1150">
                 <a:solidFill>
-                  <a:srgbClr val="0A192F"/>
+                  <a:srgbClr val="1B365D"/>
                 </a:solidFill>
               </a:defRPr>
             </a:pPr>
@@ -7058,24 +6575,24 @@
       </p:sp>
       <p:sp>
         <p:nvSpPr>
-          <p:cNvPr id="11" name="Rounded Rectangle 10"/>
+          <p:cNvPr id="10" name="Rounded Rectangle 9"/>
           <p:cNvSpPr/>
           <p:nvPr/>
         </p:nvSpPr>
         <p:spPr>
           <a:xfrm>
-            <a:off x="7955279" y="1280160"/>
-            <a:ext cx="3474720" cy="4206240"/>
+            <a:off x="7955279" y="1234440"/>
+            <a:ext cx="3474720" cy="4251960"/>
           </a:xfrm>
           <a:prstGeom prst="roundRect">
             <a:avLst/>
           </a:prstGeom>
           <a:solidFill>
-            <a:srgbClr val="F8FAFC"/>
+            <a:srgbClr val="FAFAFC"/>
           </a:solidFill>
           <a:ln w="19050">
             <a:solidFill>
-              <a:srgbClr val="FF6B00"/>
+              <a:srgbClr val="E65100"/>
             </a:solidFill>
           </a:ln>
         </p:spPr>
@@ -7100,7 +6617,7 @@
             <a:pPr algn="ctr">
               <a:defRPr b="1" sz="1150">
                 <a:solidFill>
-                  <a:srgbClr val="FF6B00"/>
+                  <a:srgbClr val="E65100"/>
                 </a:solidFill>
               </a:defRPr>
             </a:pPr>
@@ -7172,7 +6689,7 @@
       </p:sp>
       <p:sp>
         <p:nvSpPr>
-          <p:cNvPr id="12" name="Rounded Rectangle 11"/>
+          <p:cNvPr id="11" name="Rounded Rectangle 10"/>
           <p:cNvSpPr/>
           <p:nvPr/>
         </p:nvSpPr>
@@ -7189,7 +6706,7 @@
           </a:solidFill>
           <a:ln w="19050">
             <a:solidFill>
-              <a:srgbClr val="FF6B00"/>
+              <a:srgbClr val="E65100"/>
             </a:solidFill>
           </a:ln>
         </p:spPr>

</xml_diff>